<commit_message>
Revise trial lesson v2: finish tasks 1–2 with AI interaction
Tighten the 20-minute arc so both textbook tasks complete, add
three AI-assistant touchpoints with offline fallbacks, and ship an
HTML channel picker for classroom projection.

Co-authored-by: Estherqian24 <Estherqian24@users.noreply.github.com>
</commit_message>
<xml_diff>
--- a/第6课-试讲精简版-任务一二-20分钟.pptx
+++ b/第6课-试讲精简版-任务一二-20分钟.pptx
@@ -15,6 +15,7 @@
     <p:sldId id="263" r:id="rId14"/>
     <p:sldId id="264" r:id="rId15"/>
     <p:sldId id="265" r:id="rId16"/>
+    <p:sldId id="266" r:id="rId17"/>
   </p:sldIdLst>
   <p:sldSz cx="12191695" cy="6858000" type="screen4x3"/>
   <p:notesSz cx="6858000" cy="9144000"/>
@@ -3112,7 +3113,7 @@
             <a:avLst/>
           </a:prstGeom>
           <a:solidFill>
-            <a:srgbClr val="F7F9FB"/>
+            <a:srgbClr val="F4F7F8"/>
           </a:solidFill>
           <a:ln>
             <a:noFill/>
@@ -3191,8 +3192,8 @@
         </p:nvSpPr>
         <p:spPr>
           <a:xfrm>
-            <a:off x="731520" y="2011680"/>
-            <a:ext cx="10058400" cy="1097280"/>
+            <a:off x="731520" y="1828800"/>
+            <a:ext cx="10058400" cy="914400"/>
           </a:xfrm>
           <a:prstGeom prst="rect">
             <a:avLst/>
@@ -3207,7 +3208,7 @@
           <a:p>
             <a:pPr algn="l"/>
             <a:r>
-              <a:rPr sz="5400" b="1">
+              <a:rPr sz="5200" b="1">
                 <a:solidFill>
                   <a:srgbClr val="1A3A4A"/>
                 </a:solidFill>
@@ -3226,8 +3227,8 @@
         </p:nvSpPr>
         <p:spPr>
           <a:xfrm>
-            <a:off x="731520" y="3200400"/>
-            <a:ext cx="10058400" cy="457200"/>
+            <a:off x="731520" y="3017520"/>
+            <a:ext cx="10058400" cy="548640"/>
           </a:xfrm>
           <a:prstGeom prst="rect">
             <a:avLst/>
@@ -3242,13 +3243,13 @@
           <a:p>
             <a:pPr algn="l"/>
             <a:r>
-              <a:rPr sz="2400" b="0">
+              <a:rPr sz="2600" b="0">
                 <a:solidFill>
                   <a:srgbClr val="0D7A6F"/>
                 </a:solidFill>
                 <a:latin typeface="Microsoft YaHei"/>
               </a:rPr>
-              <a:t>活动一  探析物联系统中的数据传输（任务1–2）</a:t>
+              <a:t>任务1 + 任务2 完整版｜20分钟试讲</a:t>
             </a:r>
           </a:p>
         </p:txBody>
@@ -3261,7 +3262,7 @@
         </p:nvSpPr>
         <p:spPr>
           <a:xfrm>
-            <a:off x="731520" y="5029200"/>
+            <a:off x="731520" y="4846320"/>
             <a:ext cx="10058400" cy="365760"/>
           </a:xfrm>
           <a:prstGeom prst="rect">
@@ -3283,7 +3284,7 @@
                 </a:solidFill>
                 <a:latin typeface="Microsoft YaHei"/>
               </a:rPr>
-              <a:t>八年级 · 信息科技 · 试讲精简版 · 20分钟</a:t>
+              <a:t>八年级信息科技 · 互动 + AI小青 · v2</a:t>
             </a:r>
           </a:p>
         </p:txBody>
@@ -3321,7 +3322,7 @@
             <a:avLst/>
           </a:prstGeom>
           <a:solidFill>
-            <a:srgbClr val="F7F9FB"/>
+            <a:srgbClr val="F4F7F8"/>
           </a:solidFill>
           <a:ln>
             <a:noFill/>
@@ -3400,8 +3401,8 @@
         </p:nvSpPr>
         <p:spPr>
           <a:xfrm>
-            <a:off x="548640" y="320040"/>
-            <a:ext cx="10972800" cy="548640"/>
+            <a:off x="548640" y="274320"/>
+            <a:ext cx="10972800" cy="457200"/>
           </a:xfrm>
           <a:prstGeom prst="rect">
             <a:avLst/>
@@ -3416,13 +3417,13 @@
           <a:p>
             <a:pPr algn="l"/>
             <a:r>
-              <a:rPr sz="3200" b="1">
+              <a:rPr sz="2800" b="1">
                 <a:solidFill>
                   <a:srgbClr val="1A3A4A"/>
                 </a:solidFill>
                 <a:latin typeface="Microsoft YaHei"/>
               </a:rPr>
-              <a:t>本节小结（前半课）</a:t>
+              <a:t>对对碰小结：我喊场景，你喊通道</a:t>
             </a:r>
           </a:p>
         </p:txBody>
@@ -3435,8 +3436,8 @@
         </p:nvSpPr>
         <p:spPr>
           <a:xfrm>
-            <a:off x="548640" y="1188720"/>
-            <a:ext cx="3474720" cy="2926080"/>
+            <a:off x="548640" y="1097280"/>
+            <a:ext cx="3474720" cy="2743200"/>
           </a:xfrm>
           <a:prstGeom prst="roundRect">
             <a:avLst/>
@@ -3480,8 +3481,8 @@
         </p:nvSpPr>
         <p:spPr>
           <a:xfrm>
-            <a:off x="731520" y="1463040"/>
-            <a:ext cx="3108960" cy="548640"/>
+            <a:off x="731520" y="1371600"/>
+            <a:ext cx="3108960" cy="1097280"/>
           </a:xfrm>
           <a:prstGeom prst="rect">
             <a:avLst/>
@@ -3496,13 +3497,13 @@
           <a:p>
             <a:pPr algn="ctr"/>
             <a:r>
-              <a:rPr sz="2600" b="1">
-                <a:solidFill>
-                  <a:srgbClr val="0D7A6F"/>
-                </a:solidFill>
-                <a:latin typeface="Microsoft YaHei"/>
-              </a:rPr>
-              <a:t>4G/5G</a:t>
+              <a:rPr sz="2200" b="0">
+                <a:solidFill>
+                  <a:srgbClr val="1A3A4A"/>
+                </a:solidFill>
+                <a:latin typeface="Microsoft YaHei"/>
+              </a:rPr>
+              <a:t>手机查附近的车</a:t>
             </a:r>
           </a:p>
         </p:txBody>
@@ -3515,8 +3516,8 @@
         </p:nvSpPr>
         <p:spPr>
           <a:xfrm>
-            <a:off x="731520" y="2194560"/>
-            <a:ext cx="3108960" cy="457200"/>
+            <a:off x="731520" y="2743200"/>
+            <a:ext cx="3108960" cy="640080"/>
           </a:xfrm>
           <a:prstGeom prst="rect">
             <a:avLst/>
@@ -3531,62 +3532,27 @@
           <a:p>
             <a:pPr algn="ctr"/>
             <a:r>
-              <a:rPr sz="2200" b="0">
-                <a:solidFill>
-                  <a:srgbClr val="1A3A4A"/>
-                </a:solidFill>
-                <a:latin typeface="Microsoft YaHei"/>
-              </a:rPr>
-              <a:t>高速通道</a:t>
-            </a:r>
-          </a:p>
-        </p:txBody>
-      </p:sp>
-      <p:sp>
-        <p:nvSpPr>
-          <p:cNvPr id="8" name="TextBox 7"/>
-          <p:cNvSpPr txBox="1"/>
-          <p:nvPr/>
-        </p:nvSpPr>
-        <p:spPr>
-          <a:xfrm>
-            <a:off x="731520" y="2926080"/>
-            <a:ext cx="3108960" cy="731520"/>
-          </a:xfrm>
-          <a:prstGeom prst="rect">
-            <a:avLst/>
-          </a:prstGeom>
-          <a:noFill/>
-        </p:spPr>
-        <p:txBody>
-          <a:bodyPr wrap="square">
-            <a:spAutoFit/>
-          </a:bodyPr>
-          <a:lstStyle/>
-          <a:p>
-            <a:pPr algn="ctr"/>
-            <a:r>
-              <a:rPr sz="1800" b="0">
-                <a:solidFill>
-                  <a:srgbClr val="5A6A72"/>
-                </a:solidFill>
-                <a:latin typeface="Microsoft YaHei"/>
-              </a:rPr>
-              <a:t>手机↔服务器</a:t>
-            </a:r>
-          </a:p>
-        </p:txBody>
-      </p:sp>
-      <p:sp>
-        <p:nvSpPr>
-          <p:cNvPr id="9" name="Rounded Rectangle 8"/>
+              <a:rPr sz="2800" b="1">
+                <a:solidFill>
+                  <a:srgbClr val="0D7A6F"/>
+                </a:solidFill>
+                <a:latin typeface="Microsoft YaHei"/>
+              </a:rPr>
+              <a:t>4G/5G</a:t>
+            </a:r>
+          </a:p>
+        </p:txBody>
+      </p:sp>
+      <p:sp>
+        <p:nvSpPr>
+          <p:cNvPr id="8" name="Rounded Rectangle 7"/>
           <p:cNvSpPr/>
           <p:nvPr/>
         </p:nvSpPr>
         <p:spPr>
           <a:xfrm>
-            <a:off x="4297679" y="1188720"/>
-            <a:ext cx="3474720" cy="2926080"/>
+            <a:off x="4297679" y="1097280"/>
+            <a:ext cx="3474720" cy="2743200"/>
           </a:xfrm>
           <a:prstGeom prst="roundRect">
             <a:avLst/>
@@ -3624,14 +3590,14 @@
       </p:sp>
       <p:sp>
         <p:nvSpPr>
-          <p:cNvPr id="10" name="TextBox 9"/>
+          <p:cNvPr id="9" name="TextBox 8"/>
           <p:cNvSpPr txBox="1"/>
           <p:nvPr/>
         </p:nvSpPr>
         <p:spPr>
           <a:xfrm>
-            <a:off x="4480559" y="1463040"/>
-            <a:ext cx="3108960" cy="548640"/>
+            <a:off x="4480559" y="1371600"/>
+            <a:ext cx="3108960" cy="1097280"/>
           </a:xfrm>
           <a:prstGeom prst="rect">
             <a:avLst/>
@@ -3646,27 +3612,27 @@
           <a:p>
             <a:pPr algn="ctr"/>
             <a:r>
-              <a:rPr sz="2600" b="1">
-                <a:solidFill>
-                  <a:srgbClr val="0D7A6F"/>
-                </a:solidFill>
-                <a:latin typeface="Microsoft YaHei"/>
-              </a:rPr>
-              <a:t>NB-IoT</a:t>
-            </a:r>
-          </a:p>
-        </p:txBody>
-      </p:sp>
-      <p:sp>
-        <p:nvSpPr>
-          <p:cNvPr id="11" name="TextBox 10"/>
+              <a:rPr sz="2200" b="0">
+                <a:solidFill>
+                  <a:srgbClr val="1A3A4A"/>
+                </a:solidFill>
+                <a:latin typeface="Microsoft YaHei"/>
+              </a:rPr>
+              <a:t>单车汇报位置</a:t>
+            </a:r>
+          </a:p>
+        </p:txBody>
+      </p:sp>
+      <p:sp>
+        <p:nvSpPr>
+          <p:cNvPr id="10" name="TextBox 9"/>
           <p:cNvSpPr txBox="1"/>
           <p:nvPr/>
         </p:nvSpPr>
         <p:spPr>
           <a:xfrm>
-            <a:off x="4480559" y="2194560"/>
-            <a:ext cx="3108960" cy="457200"/>
+            <a:off x="4480559" y="2743200"/>
+            <a:ext cx="3108960" cy="640080"/>
           </a:xfrm>
           <a:prstGeom prst="rect">
             <a:avLst/>
@@ -3681,62 +3647,27 @@
           <a:p>
             <a:pPr algn="ctr"/>
             <a:r>
-              <a:rPr sz="2200" b="0">
-                <a:solidFill>
-                  <a:srgbClr val="1A3A4A"/>
-                </a:solidFill>
-                <a:latin typeface="Microsoft YaHei"/>
-              </a:rPr>
-              <a:t>省电长跑</a:t>
-            </a:r>
-          </a:p>
-        </p:txBody>
-      </p:sp>
-      <p:sp>
-        <p:nvSpPr>
-          <p:cNvPr id="12" name="TextBox 11"/>
-          <p:cNvSpPr txBox="1"/>
-          <p:nvPr/>
-        </p:nvSpPr>
-        <p:spPr>
-          <a:xfrm>
-            <a:off x="4480559" y="2926080"/>
-            <a:ext cx="3108960" cy="731520"/>
-          </a:xfrm>
-          <a:prstGeom prst="rect">
-            <a:avLst/>
-          </a:prstGeom>
-          <a:noFill/>
-        </p:spPr>
-        <p:txBody>
-          <a:bodyPr wrap="square">
-            <a:spAutoFit/>
-          </a:bodyPr>
-          <a:lstStyle/>
-          <a:p>
-            <a:pPr algn="ctr"/>
-            <a:r>
-              <a:rPr sz="1800" b="0">
-                <a:solidFill>
-                  <a:srgbClr val="5A6A72"/>
-                </a:solidFill>
-                <a:latin typeface="Microsoft YaHei"/>
-              </a:rPr>
-              <a:t>单车↔服务器</a:t>
-            </a:r>
-          </a:p>
-        </p:txBody>
-      </p:sp>
-      <p:sp>
-        <p:nvSpPr>
-          <p:cNvPr id="13" name="Rounded Rectangle 12"/>
+              <a:rPr sz="2800" b="1">
+                <a:solidFill>
+                  <a:srgbClr val="0D7A6F"/>
+                </a:solidFill>
+                <a:latin typeface="Microsoft YaHei"/>
+              </a:rPr>
+              <a:t>NB-IoT</a:t>
+            </a:r>
+          </a:p>
+        </p:txBody>
+      </p:sp>
+      <p:sp>
+        <p:nvSpPr>
+          <p:cNvPr id="11" name="Rounded Rectangle 10"/>
           <p:cNvSpPr/>
           <p:nvPr/>
         </p:nvSpPr>
         <p:spPr>
           <a:xfrm>
-            <a:off x="8046719" y="1188720"/>
-            <a:ext cx="3474720" cy="2926080"/>
+            <a:off x="8046719" y="1097280"/>
+            <a:ext cx="3474720" cy="2743200"/>
           </a:xfrm>
           <a:prstGeom prst="roundRect">
             <a:avLst/>
@@ -3774,14 +3705,14 @@
       </p:sp>
       <p:sp>
         <p:nvSpPr>
-          <p:cNvPr id="14" name="TextBox 13"/>
+          <p:cNvPr id="12" name="TextBox 11"/>
           <p:cNvSpPr txBox="1"/>
           <p:nvPr/>
         </p:nvSpPr>
         <p:spPr>
           <a:xfrm>
-            <a:off x="8229599" y="1463040"/>
-            <a:ext cx="3108960" cy="548640"/>
+            <a:off x="8229599" y="1371600"/>
+            <a:ext cx="3108960" cy="1097280"/>
           </a:xfrm>
           <a:prstGeom prst="rect">
             <a:avLst/>
@@ -3796,27 +3727,27 @@
           <a:p>
             <a:pPr algn="ctr"/>
             <a:r>
-              <a:rPr sz="2600" b="1">
-                <a:solidFill>
-                  <a:srgbClr val="0D7A6F"/>
-                </a:solidFill>
-                <a:latin typeface="Microsoft YaHei"/>
-              </a:rPr>
-              <a:t>蓝牙</a:t>
-            </a:r>
-          </a:p>
-        </p:txBody>
-      </p:sp>
-      <p:sp>
-        <p:nvSpPr>
-          <p:cNvPr id="15" name="TextBox 14"/>
+              <a:rPr sz="2200" b="0">
+                <a:solidFill>
+                  <a:srgbClr val="1A3A4A"/>
+                </a:solidFill>
+                <a:latin typeface="Microsoft YaHei"/>
+              </a:rPr>
+              <a:t>地下车库辅助开锁</a:t>
+            </a:r>
+          </a:p>
+        </p:txBody>
+      </p:sp>
+      <p:sp>
+        <p:nvSpPr>
+          <p:cNvPr id="13" name="TextBox 12"/>
           <p:cNvSpPr txBox="1"/>
           <p:nvPr/>
         </p:nvSpPr>
         <p:spPr>
           <a:xfrm>
-            <a:off x="8229599" y="2194560"/>
-            <a:ext cx="3108960" cy="457200"/>
+            <a:off x="8229599" y="2743200"/>
+            <a:ext cx="3108960" cy="640080"/>
           </a:xfrm>
           <a:prstGeom prst="rect">
             <a:avLst/>
@@ -3831,27 +3762,27 @@
           <a:p>
             <a:pPr algn="ctr"/>
             <a:r>
-              <a:rPr sz="2200" b="0">
-                <a:solidFill>
-                  <a:srgbClr val="1A3A4A"/>
-                </a:solidFill>
-                <a:latin typeface="Microsoft YaHei"/>
-              </a:rPr>
-              <a:t>贴身短距</a:t>
-            </a:r>
-          </a:p>
-        </p:txBody>
-      </p:sp>
-      <p:sp>
-        <p:nvSpPr>
-          <p:cNvPr id="16" name="TextBox 15"/>
+              <a:rPr sz="2800" b="1">
+                <a:solidFill>
+                  <a:srgbClr val="0D7A6F"/>
+                </a:solidFill>
+                <a:latin typeface="Microsoft YaHei"/>
+              </a:rPr>
+              <a:t>蓝牙</a:t>
+            </a:r>
+          </a:p>
+        </p:txBody>
+      </p:sp>
+      <p:sp>
+        <p:nvSpPr>
+          <p:cNvPr id="14" name="TextBox 13"/>
           <p:cNvSpPr txBox="1"/>
           <p:nvPr/>
         </p:nvSpPr>
         <p:spPr>
           <a:xfrm>
-            <a:off x="8229599" y="2926080"/>
-            <a:ext cx="3108960" cy="731520"/>
+            <a:off x="548640" y="4206240"/>
+            <a:ext cx="10972800" cy="1645920"/>
           </a:xfrm>
           <a:prstGeom prst="rect">
             <a:avLst/>
@@ -3864,29 +3795,53 @@
           </a:bodyPr>
           <a:lstStyle/>
           <a:p>
-            <a:pPr algn="ctr"/>
-            <a:r>
-              <a:rPr sz="1800" b="0">
-                <a:solidFill>
-                  <a:srgbClr val="5A6A72"/>
-                </a:solidFill>
-                <a:latin typeface="Microsoft YaHei"/>
-              </a:rPr>
-              <a:t>手机↔车锁补位</a:t>
-            </a:r>
-          </a:p>
-        </p:txBody>
-      </p:sp>
-      <p:sp>
-        <p:nvSpPr>
-          <p:cNvPr id="17" name="TextBox 16"/>
+            <a:pPr algn="l"/>
+            <a:r>
+              <a:rPr sz="2400" b="1">
+                <a:solidFill>
+                  <a:srgbClr val="1A3A4A"/>
+                </a:solidFill>
+                <a:latin typeface="Microsoft YaHei"/>
+              </a:rPr>
+              <a:t>结论：数据会旅行；路不止一条；</a:t>
+            </a:r>
+          </a:p>
+          <a:p>
+            <a:pPr algn="l"/>
+            <a:r>
+              <a:rPr sz="2400" b="1">
+                <a:solidFill>
+                  <a:srgbClr val="1A3A4A"/>
+                </a:solidFill>
+                <a:latin typeface="Microsoft YaHei"/>
+              </a:rPr>
+              <a:t>选哪条，看距离、功耗和场景。</a:t>
+            </a:r>
+          </a:p>
+          <a:p>
+            <a:pPr algn="l"/>
+            <a:r>
+              <a:rPr sz="2400" b="1">
+                <a:solidFill>
+                  <a:srgbClr val="1A3A4A"/>
+                </a:solidFill>
+                <a:latin typeface="Microsoft YaHei"/>
+              </a:rPr>
+              <a:t>→ 所以“全都用Wi-Fi”不完整！</a:t>
+            </a:r>
+          </a:p>
+        </p:txBody>
+      </p:sp>
+      <p:sp>
+        <p:nvSpPr>
+          <p:cNvPr id="15" name="TextBox 14"/>
           <p:cNvSpPr txBox="1"/>
           <p:nvPr/>
         </p:nvSpPr>
         <p:spPr>
           <a:xfrm>
-            <a:off x="548640" y="4389120"/>
-            <a:ext cx="10972800" cy="1371600"/>
+            <a:off x="457200" y="6446520"/>
+            <a:ext cx="11247120" cy="320040"/>
           </a:xfrm>
           <a:prstGeom prst="rect">
             <a:avLst/>
@@ -3901,39 +3856,131 @@
           <a:p>
             <a:pPr algn="l"/>
             <a:r>
-              <a:rPr sz="2400" b="1">
-                <a:solidFill>
-                  <a:srgbClr val="1A3A4A"/>
-                </a:solidFill>
-                <a:latin typeface="Microsoft YaHei"/>
-              </a:rPr>
-              <a:t>结论：物联网里数据会旅行；旅行的路不止一条；</a:t>
-            </a:r>
-          </a:p>
-          <a:p>
-            <a:pPr algn="l"/>
-            <a:r>
-              <a:rPr sz="2400" b="1">
-                <a:solidFill>
-                  <a:srgbClr val="1A3A4A"/>
-                </a:solidFill>
-                <a:latin typeface="Microsoft YaHei"/>
-              </a:rPr>
-              <a:t>选哪条，看距离、功耗和场景。</a:t>
-            </a:r>
-          </a:p>
-        </p:txBody>
-      </p:sp>
-      <p:sp>
-        <p:nvSpPr>
-          <p:cNvPr id="18" name="TextBox 17"/>
+              <a:rPr sz="1300" b="0">
+                <a:solidFill>
+                  <a:srgbClr val="5A6A72"/>
+                </a:solidFill>
+                <a:latin typeface="Microsoft YaHei"/>
+              </a:rPr>
+              <a:t>16:30必须进入本页｜19:00进AI收束</a:t>
+            </a:r>
+          </a:p>
+        </p:txBody>
+      </p:sp>
+    </p:spTree>
+  </p:cSld>
+  <p:clrMapOvr>
+    <a:masterClrMapping/>
+  </p:clrMapOvr>
+</p:sld>
+</file>
+
+<file path=ppt/slides/slide11.xml><?xml version="1.0" encoding="utf-8"?>
+<p:sld xmlns:a="http://schemas.openxmlformats.org/drawingml/2006/main" xmlns:p="http://schemas.openxmlformats.org/presentationml/2006/main" xmlns:r="http://schemas.openxmlformats.org/officeDocument/2006/relationships">
+  <p:cSld>
+    <p:spTree>
+      <p:nvGrpSpPr>
+        <p:cNvPr id="1" name=""/>
+        <p:cNvGrpSpPr/>
+        <p:nvPr/>
+      </p:nvGrpSpPr>
+      <p:grpSpPr/>
+      <p:sp>
+        <p:nvSpPr>
+          <p:cNvPr id="2" name="Rectangle 1"/>
+          <p:cNvSpPr/>
+          <p:nvPr/>
+        </p:nvSpPr>
+        <p:spPr>
+          <a:xfrm>
+            <a:off x="0" y="0"/>
+            <a:ext cx="12191695" cy="6858000"/>
+          </a:xfrm>
+          <a:prstGeom prst="rect">
+            <a:avLst/>
+          </a:prstGeom>
+          <a:solidFill>
+            <a:srgbClr val="F4F7F8"/>
+          </a:solidFill>
+          <a:ln>
+            <a:noFill/>
+          </a:ln>
+        </p:spPr>
+        <p:style>
+          <a:lnRef idx="1">
+            <a:schemeClr val="accent1"/>
+          </a:lnRef>
+          <a:fillRef idx="3">
+            <a:schemeClr val="accent1"/>
+          </a:fillRef>
+          <a:effectRef idx="2">
+            <a:schemeClr val="accent1"/>
+          </a:effectRef>
+          <a:fontRef idx="minor">
+            <a:schemeClr val="lt1"/>
+          </a:fontRef>
+        </p:style>
+        <p:txBody>
+          <a:bodyPr rtlCol="0" anchor="ctr"/>
+          <a:lstStyle/>
+          <a:p>
+            <a:pPr algn="ctr"/>
+          </a:p>
+        </p:txBody>
+      </p:sp>
+      <p:sp>
+        <p:nvSpPr>
+          <p:cNvPr id="3" name="Rectangle 2"/>
+          <p:cNvSpPr/>
+          <p:nvPr/>
+        </p:nvSpPr>
+        <p:spPr>
+          <a:xfrm>
+            <a:off x="0" y="0"/>
+            <a:ext cx="164592" cy="6858000"/>
+          </a:xfrm>
+          <a:prstGeom prst="rect">
+            <a:avLst/>
+          </a:prstGeom>
+          <a:solidFill>
+            <a:srgbClr val="0D7A6F"/>
+          </a:solidFill>
+          <a:ln>
+            <a:noFill/>
+          </a:ln>
+        </p:spPr>
+        <p:style>
+          <a:lnRef idx="1">
+            <a:schemeClr val="accent1"/>
+          </a:lnRef>
+          <a:fillRef idx="3">
+            <a:schemeClr val="accent1"/>
+          </a:fillRef>
+          <a:effectRef idx="2">
+            <a:schemeClr val="accent1"/>
+          </a:effectRef>
+          <a:fontRef idx="minor">
+            <a:schemeClr val="lt1"/>
+          </a:fontRef>
+        </p:style>
+        <p:txBody>
+          <a:bodyPr rtlCol="0" anchor="ctr"/>
+          <a:lstStyle/>
+          <a:p>
+            <a:pPr algn="ctr"/>
+          </a:p>
+        </p:txBody>
+      </p:sp>
+      <p:sp>
+        <p:nvSpPr>
+          <p:cNvPr id="4" name="TextBox 3"/>
           <p:cNvSpPr txBox="1"/>
           <p:nvPr/>
         </p:nvSpPr>
         <p:spPr>
           <a:xfrm>
-            <a:off x="457200" y="6446520"/>
-            <a:ext cx="10972800" cy="320040"/>
+            <a:off x="548640" y="274320"/>
+            <a:ext cx="10972800" cy="457200"/>
           </a:xfrm>
           <a:prstGeom prst="rect">
             <a:avLst/>
@@ -3948,13 +3995,393 @@
           <a:p>
             <a:pPr algn="l"/>
             <a:r>
-              <a:rPr sz="1400" b="0">
+              <a:rPr sz="2800" b="1">
+                <a:solidFill>
+                  <a:srgbClr val="1A3A4A"/>
+                </a:solidFill>
+                <a:latin typeface="Microsoft YaHei"/>
+              </a:rPr>
+              <a:t>备援页：小青预置回答（无网可用）</a:t>
+            </a:r>
+          </a:p>
+        </p:txBody>
+      </p:sp>
+      <p:sp>
+        <p:nvSpPr>
+          <p:cNvPr id="5" name="Rounded Rectangle 4"/>
+          <p:cNvSpPr/>
+          <p:nvPr/>
+        </p:nvSpPr>
+        <p:spPr>
+          <a:xfrm>
+            <a:off x="548640" y="914400"/>
+            <a:ext cx="10972800" cy="1554480"/>
+          </a:xfrm>
+          <a:prstGeom prst="roundRect">
+            <a:avLst/>
+          </a:prstGeom>
+          <a:solidFill>
+            <a:srgbClr val="E6F3F1"/>
+          </a:solidFill>
+          <a:ln w="12700">
+            <a:solidFill>
+              <a:srgbClr val="D0DAE0"/>
+            </a:solidFill>
+          </a:ln>
+        </p:spPr>
+        <p:style>
+          <a:lnRef idx="1">
+            <a:schemeClr val="accent1"/>
+          </a:lnRef>
+          <a:fillRef idx="3">
+            <a:schemeClr val="accent1"/>
+          </a:fillRef>
+          <a:effectRef idx="2">
+            <a:schemeClr val="accent1"/>
+          </a:effectRef>
+          <a:fontRef idx="minor">
+            <a:schemeClr val="lt1"/>
+          </a:fontRef>
+        </p:style>
+        <p:txBody>
+          <a:bodyPr rtlCol="0" anchor="ctr"/>
+          <a:lstStyle/>
+          <a:p>
+            <a:pPr algn="ctr"/>
+          </a:p>
+        </p:txBody>
+      </p:sp>
+      <p:sp>
+        <p:nvSpPr>
+          <p:cNvPr id="6" name="TextBox 5"/>
+          <p:cNvSpPr txBox="1"/>
+          <p:nvPr/>
+        </p:nvSpPr>
+        <p:spPr>
+          <a:xfrm>
+            <a:off x="822960" y="1143000"/>
+            <a:ext cx="10424160" cy="365760"/>
+          </a:xfrm>
+          <a:prstGeom prst="rect">
+            <a:avLst/>
+          </a:prstGeom>
+          <a:noFill/>
+        </p:spPr>
+        <p:txBody>
+          <a:bodyPr wrap="square">
+            <a:spAutoFit/>
+          </a:bodyPr>
+          <a:lstStyle/>
+          <a:p>
+            <a:pPr algn="l"/>
+            <a:r>
+              <a:rPr sz="1800" b="1">
+                <a:solidFill>
+                  <a:srgbClr val="0D7A6F"/>
+                </a:solidFill>
+                <a:latin typeface="Microsoft YaHei"/>
+              </a:rPr>
+              <a:t>AI-1 钩子</a:t>
+            </a:r>
+          </a:p>
+        </p:txBody>
+      </p:sp>
+      <p:sp>
+        <p:nvSpPr>
+          <p:cNvPr id="7" name="TextBox 6"/>
+          <p:cNvSpPr txBox="1"/>
+          <p:nvPr/>
+        </p:nvSpPr>
+        <p:spPr>
+          <a:xfrm>
+            <a:off x="822960" y="1600200"/>
+            <a:ext cx="10424160" cy="640080"/>
+          </a:xfrm>
+          <a:prstGeom prst="rect">
+            <a:avLst/>
+          </a:prstGeom>
+          <a:noFill/>
+        </p:spPr>
+        <p:txBody>
+          <a:bodyPr wrap="square">
+            <a:spAutoFit/>
+          </a:bodyPr>
+          <a:lstStyle/>
+          <a:p>
+            <a:pPr algn="l"/>
+            <a:r>
+              <a:rPr sz="2000" b="0">
+                <a:solidFill>
+                  <a:srgbClr val="1A3A4A"/>
+                </a:solidFill>
+                <a:latin typeface="Microsoft YaHei"/>
+              </a:rPr>
+              <a:t>小青：可以呀，Wi-Fi很方便，共享单车都用Wi-Fi就行。</a:t>
+            </a:r>
+          </a:p>
+        </p:txBody>
+      </p:sp>
+      <p:sp>
+        <p:nvSpPr>
+          <p:cNvPr id="8" name="Rounded Rectangle 7"/>
+          <p:cNvSpPr/>
+          <p:nvPr/>
+        </p:nvSpPr>
+        <p:spPr>
+          <a:xfrm>
+            <a:off x="548640" y="2606040"/>
+            <a:ext cx="10972800" cy="1554480"/>
+          </a:xfrm>
+          <a:prstGeom prst="roundRect">
+            <a:avLst/>
+          </a:prstGeom>
+          <a:solidFill>
+            <a:srgbClr val="FFFFFF"/>
+          </a:solidFill>
+          <a:ln w="12700">
+            <a:solidFill>
+              <a:srgbClr val="D0DAE0"/>
+            </a:solidFill>
+          </a:ln>
+        </p:spPr>
+        <p:style>
+          <a:lnRef idx="1">
+            <a:schemeClr val="accent1"/>
+          </a:lnRef>
+          <a:fillRef idx="3">
+            <a:schemeClr val="accent1"/>
+          </a:fillRef>
+          <a:effectRef idx="2">
+            <a:schemeClr val="accent1"/>
+          </a:effectRef>
+          <a:fontRef idx="minor">
+            <a:schemeClr val="lt1"/>
+          </a:fontRef>
+        </p:style>
+        <p:txBody>
+          <a:bodyPr rtlCol="0" anchor="ctr"/>
+          <a:lstStyle/>
+          <a:p>
+            <a:pPr algn="ctr"/>
+          </a:p>
+        </p:txBody>
+      </p:sp>
+      <p:sp>
+        <p:nvSpPr>
+          <p:cNvPr id="9" name="TextBox 8"/>
+          <p:cNvSpPr txBox="1"/>
+          <p:nvPr/>
+        </p:nvSpPr>
+        <p:spPr>
+          <a:xfrm>
+            <a:off x="822960" y="2834640"/>
+            <a:ext cx="10424160" cy="365760"/>
+          </a:xfrm>
+          <a:prstGeom prst="rect">
+            <a:avLst/>
+          </a:prstGeom>
+          <a:noFill/>
+        </p:spPr>
+        <p:txBody>
+          <a:bodyPr wrap="square">
+            <a:spAutoFit/>
+          </a:bodyPr>
+          <a:lstStyle/>
+          <a:p>
+            <a:pPr algn="l"/>
+            <a:r>
+              <a:rPr sz="1800" b="1">
+                <a:solidFill>
+                  <a:srgbClr val="0D7A6F"/>
+                </a:solidFill>
+                <a:latin typeface="Microsoft YaHei"/>
+              </a:rPr>
+              <a:t>AI-2 开锁</a:t>
+            </a:r>
+          </a:p>
+        </p:txBody>
+      </p:sp>
+      <p:sp>
+        <p:nvSpPr>
+          <p:cNvPr id="10" name="TextBox 9"/>
+          <p:cNvSpPr txBox="1"/>
+          <p:nvPr/>
+        </p:nvSpPr>
+        <p:spPr>
+          <a:xfrm>
+            <a:off x="822960" y="3291840"/>
+            <a:ext cx="10424160" cy="640080"/>
+          </a:xfrm>
+          <a:prstGeom prst="rect">
+            <a:avLst/>
+          </a:prstGeom>
+          <a:noFill/>
+        </p:spPr>
+        <p:txBody>
+          <a:bodyPr wrap="square">
+            <a:spAutoFit/>
+          </a:bodyPr>
+          <a:lstStyle/>
+          <a:p>
+            <a:pPr algn="l"/>
+            <a:r>
+              <a:rPr sz="2000" b="0">
+                <a:solidFill>
+                  <a:srgbClr val="1A3A4A"/>
+                </a:solidFill>
+                <a:latin typeface="Microsoft YaHei"/>
+              </a:rPr>
+              <a:t>小青：地下室信号差时，只靠远程通道可能不稳，还可用蓝牙近距离辅助开锁。</a:t>
+            </a:r>
+          </a:p>
+        </p:txBody>
+      </p:sp>
+      <p:sp>
+        <p:nvSpPr>
+          <p:cNvPr id="11" name="Rounded Rectangle 10"/>
+          <p:cNvSpPr/>
+          <p:nvPr/>
+        </p:nvSpPr>
+        <p:spPr>
+          <a:xfrm>
+            <a:off x="548640" y="4297680"/>
+            <a:ext cx="10972800" cy="1554480"/>
+          </a:xfrm>
+          <a:prstGeom prst="roundRect">
+            <a:avLst/>
+          </a:prstGeom>
+          <a:solidFill>
+            <a:srgbClr val="E6F3F1"/>
+          </a:solidFill>
+          <a:ln w="12700">
+            <a:solidFill>
+              <a:srgbClr val="D0DAE0"/>
+            </a:solidFill>
+          </a:ln>
+        </p:spPr>
+        <p:style>
+          <a:lnRef idx="1">
+            <a:schemeClr val="accent1"/>
+          </a:lnRef>
+          <a:fillRef idx="3">
+            <a:schemeClr val="accent1"/>
+          </a:fillRef>
+          <a:effectRef idx="2">
+            <a:schemeClr val="accent1"/>
+          </a:effectRef>
+          <a:fontRef idx="minor">
+            <a:schemeClr val="lt1"/>
+          </a:fontRef>
+        </p:style>
+        <p:txBody>
+          <a:bodyPr rtlCol="0" anchor="ctr"/>
+          <a:lstStyle/>
+          <a:p>
+            <a:pPr algn="ctr"/>
+          </a:p>
+        </p:txBody>
+      </p:sp>
+      <p:sp>
+        <p:nvSpPr>
+          <p:cNvPr id="12" name="TextBox 11"/>
+          <p:cNvSpPr txBox="1"/>
+          <p:nvPr/>
+        </p:nvSpPr>
+        <p:spPr>
+          <a:xfrm>
+            <a:off x="822960" y="4526280"/>
+            <a:ext cx="10424160" cy="365760"/>
+          </a:xfrm>
+          <a:prstGeom prst="rect">
+            <a:avLst/>
+          </a:prstGeom>
+          <a:noFill/>
+        </p:spPr>
+        <p:txBody>
+          <a:bodyPr wrap="square">
+            <a:spAutoFit/>
+          </a:bodyPr>
+          <a:lstStyle/>
+          <a:p>
+            <a:pPr algn="l"/>
+            <a:r>
+              <a:rPr sz="1800" b="1">
+                <a:solidFill>
+                  <a:srgbClr val="0D7A6F"/>
+                </a:solidFill>
+                <a:latin typeface="Microsoft YaHei"/>
+              </a:rPr>
+              <a:t>AI-3 收束</a:t>
+            </a:r>
+          </a:p>
+        </p:txBody>
+      </p:sp>
+      <p:sp>
+        <p:nvSpPr>
+          <p:cNvPr id="13" name="TextBox 12"/>
+          <p:cNvSpPr txBox="1"/>
+          <p:nvPr/>
+        </p:nvSpPr>
+        <p:spPr>
+          <a:xfrm>
+            <a:off x="822960" y="4983480"/>
+            <a:ext cx="10424160" cy="640080"/>
+          </a:xfrm>
+          <a:prstGeom prst="rect">
+            <a:avLst/>
+          </a:prstGeom>
+          <a:noFill/>
+        </p:spPr>
+        <p:txBody>
+          <a:bodyPr wrap="square">
+            <a:spAutoFit/>
+          </a:bodyPr>
+          <a:lstStyle/>
+          <a:p>
+            <a:pPr algn="l"/>
+            <a:r>
+              <a:rPr sz="2000" b="0">
+                <a:solidFill>
+                  <a:srgbClr val="1A3A4A"/>
+                </a:solidFill>
+                <a:latin typeface="Microsoft YaHei"/>
+              </a:rPr>
+              <a:t>小青：因为很多设备要省电、要传得远、数据又不大，不能全靠高耗电高速网络。</a:t>
+            </a:r>
+          </a:p>
+        </p:txBody>
+      </p:sp>
+      <p:sp>
+        <p:nvSpPr>
+          <p:cNvPr id="14" name="TextBox 13"/>
+          <p:cNvSpPr txBox="1"/>
+          <p:nvPr/>
+        </p:nvSpPr>
+        <p:spPr>
+          <a:xfrm>
+            <a:off x="457200" y="6446520"/>
+            <a:ext cx="11247120" cy="320040"/>
+          </a:xfrm>
+          <a:prstGeom prst="rect">
+            <a:avLst/>
+          </a:prstGeom>
+          <a:noFill/>
+        </p:spPr>
+        <p:txBody>
+          <a:bodyPr wrap="square">
+            <a:spAutoFit/>
+          </a:bodyPr>
+          <a:lstStyle/>
+          <a:p>
+            <a:pPr algn="l"/>
+            <a:r>
+              <a:rPr sz="1300" b="0">
                 <a:solidFill>
                   <a:srgbClr val="5A6A72"/>
                 </a:solidFill>
                 <a:latin typeface="Microsoft YaHei"/>
               </a:rPr>
-              <a:t>跟读结论｜预告下半节：有线/无线与更多方式比较</a:t>
+              <a:t>现场AI失败时直接读气泡，流程不中断｜仍要求学生判断对错</a:t>
             </a:r>
           </a:p>
         </p:txBody>
@@ -3992,7 +4419,7 @@
             <a:avLst/>
           </a:prstGeom>
           <a:solidFill>
-            <a:srgbClr val="F7F9FB"/>
+            <a:srgbClr val="F4F7F8"/>
           </a:solidFill>
           <a:ln>
             <a:noFill/>
@@ -4071,8 +4498,8 @@
         </p:nvSpPr>
         <p:spPr>
           <a:xfrm>
-            <a:off x="548640" y="365760"/>
-            <a:ext cx="10972800" cy="640080"/>
+            <a:off x="548640" y="320040"/>
+            <a:ext cx="10972800" cy="548640"/>
           </a:xfrm>
           <a:prstGeom prst="rect">
             <a:avLst/>
@@ -4087,13 +4514,13 @@
           <a:p>
             <a:pPr algn="l"/>
             <a:r>
-              <a:rPr sz="3600" b="1">
+              <a:rPr sz="3400" b="1">
                 <a:solidFill>
                   <a:srgbClr val="1A3A4A"/>
                 </a:solidFill>
                 <a:latin typeface="Microsoft YaHei"/>
               </a:rPr>
-              <a:t>今天我们要解决</a:t>
+              <a:t>今天两个任务都要完成</a:t>
             </a:r>
           </a:p>
         </p:txBody>
@@ -4106,8 +4533,8 @@
         </p:nvSpPr>
         <p:spPr>
           <a:xfrm>
-            <a:off x="548640" y="1371600"/>
-            <a:ext cx="10972800" cy="1828800"/>
+            <a:off x="548640" y="1188720"/>
+            <a:ext cx="5303520" cy="3840480"/>
           </a:xfrm>
           <a:prstGeom prst="roundRect">
             <a:avLst/>
@@ -4151,8 +4578,8 @@
         </p:nvSpPr>
         <p:spPr>
           <a:xfrm>
-            <a:off x="914400" y="1645920"/>
-            <a:ext cx="10058400" cy="1280160"/>
+            <a:off x="822960" y="1463040"/>
+            <a:ext cx="4754880" cy="457200"/>
           </a:xfrm>
           <a:prstGeom prst="rect">
             <a:avLst/>
@@ -4167,25 +4594,13 @@
           <a:p>
             <a:pPr algn="l"/>
             <a:r>
-              <a:rPr sz="2800" b="1">
-                <a:solidFill>
-                  <a:srgbClr val="1A3A4A"/>
-                </a:solidFill>
-                <a:latin typeface="Microsoft YaHei"/>
-              </a:rPr>
-              <a:t>① 共享单车物联系统里，数据是怎么“旅行”的？</a:t>
-            </a:r>
-          </a:p>
-          <a:p>
-            <a:pPr algn="l"/>
-            <a:r>
-              <a:rPr sz="2800" b="1">
-                <a:solidFill>
-                  <a:srgbClr val="1A3A4A"/>
-                </a:solidFill>
-                <a:latin typeface="Microsoft YaHei"/>
-              </a:rPr>
-              <a:t>② 为什么不能只用一种数据传输方式？</a:t>
+              <a:rPr sz="2200" b="1">
+                <a:solidFill>
+                  <a:srgbClr val="0D7A6F"/>
+                </a:solidFill>
+                <a:latin typeface="Microsoft YaHei"/>
+              </a:rPr>
+              <a:t>任务1</a:t>
             </a:r>
           </a:p>
         </p:txBody>
@@ -4198,8 +4613,8 @@
         </p:nvSpPr>
         <p:spPr>
           <a:xfrm>
-            <a:off x="548640" y="3657600"/>
-            <a:ext cx="10972800" cy="1371600"/>
+            <a:off x="822960" y="2103120"/>
+            <a:ext cx="4754880" cy="2560320"/>
           </a:xfrm>
           <a:prstGeom prst="rect">
             <a:avLst/>
@@ -4216,11 +4631,11 @@
             <a:r>
               <a:rPr sz="2200" b="0">
                 <a:solidFill>
-                  <a:srgbClr val="5A6A72"/>
-                </a:solidFill>
-                <a:latin typeface="Microsoft YaHei"/>
-              </a:rPr>
-              <a:t>学习提示：先说生活过程 → 再找数据路径 → 最后给通道起名字</a:t>
+                  <a:srgbClr val="1A3A4A"/>
+                </a:solidFill>
+                <a:latin typeface="Microsoft YaHei"/>
+              </a:rPr>
+              <a:t>说一说共享单车的使用过程</a:t>
             </a:r>
           </a:p>
           <a:p>
@@ -4228,25 +4643,94 @@
             <a:r>
               <a:rPr sz="2200" b="0">
                 <a:solidFill>
-                  <a:srgbClr val="5A6A72"/>
-                </a:solidFill>
-                <a:latin typeface="Microsoft YaHei"/>
-              </a:rPr>
-              <a:t>（4G/5G、NB-IoT、蓝牙）</a:t>
-            </a:r>
-          </a:p>
-        </p:txBody>
-      </p:sp>
-      <p:sp>
-        <p:nvSpPr>
-          <p:cNvPr id="8" name="TextBox 7"/>
+                  <a:srgbClr val="1A3A4A"/>
+                </a:solidFill>
+                <a:latin typeface="Microsoft YaHei"/>
+              </a:rPr>
+              <a:t/>
+            </a:r>
+          </a:p>
+          <a:p>
+            <a:pPr algn="l"/>
+            <a:r>
+              <a:rPr sz="2200" b="0">
+                <a:solidFill>
+                  <a:srgbClr val="1A3A4A"/>
+                </a:solidFill>
+                <a:latin typeface="Microsoft YaHei"/>
+              </a:rPr>
+              <a:t>排出顺序</a:t>
+            </a:r>
+          </a:p>
+          <a:p>
+            <a:pPr algn="l"/>
+            <a:r>
+              <a:rPr sz="2200" b="0">
+                <a:solidFill>
+                  <a:srgbClr val="1A3A4A"/>
+                </a:solidFill>
+                <a:latin typeface="Microsoft YaHei"/>
+              </a:rPr>
+              <a:t>看见数据在谁和谁之间流动</a:t>
+            </a:r>
+          </a:p>
+        </p:txBody>
+      </p:sp>
+      <p:sp>
+        <p:nvSpPr>
+          <p:cNvPr id="8" name="Rounded Rectangle 7"/>
+          <p:cNvSpPr/>
+          <p:nvPr/>
+        </p:nvSpPr>
+        <p:spPr>
+          <a:xfrm>
+            <a:off x="6309360" y="1188720"/>
+            <a:ext cx="5303520" cy="3840480"/>
+          </a:xfrm>
+          <a:prstGeom prst="roundRect">
+            <a:avLst/>
+          </a:prstGeom>
+          <a:solidFill>
+            <a:srgbClr val="FFFFFF"/>
+          </a:solidFill>
+          <a:ln w="12700">
+            <a:solidFill>
+              <a:srgbClr val="D0DAE0"/>
+            </a:solidFill>
+          </a:ln>
+        </p:spPr>
+        <p:style>
+          <a:lnRef idx="1">
+            <a:schemeClr val="accent1"/>
+          </a:lnRef>
+          <a:fillRef idx="3">
+            <a:schemeClr val="accent1"/>
+          </a:fillRef>
+          <a:effectRef idx="2">
+            <a:schemeClr val="accent1"/>
+          </a:effectRef>
+          <a:fontRef idx="minor">
+            <a:schemeClr val="lt1"/>
+          </a:fontRef>
+        </p:style>
+        <p:txBody>
+          <a:bodyPr rtlCol="0" anchor="ctr"/>
+          <a:lstStyle/>
+          <a:p>
+            <a:pPr algn="ctr"/>
+          </a:p>
+        </p:txBody>
+      </p:sp>
+      <p:sp>
+        <p:nvSpPr>
+          <p:cNvPr id="9" name="TextBox 8"/>
           <p:cNvSpPr txBox="1"/>
           <p:nvPr/>
         </p:nvSpPr>
         <p:spPr>
           <a:xfrm>
-            <a:off x="457200" y="6446520"/>
-            <a:ext cx="10972800" cy="320040"/>
+            <a:off x="6583680" y="1463040"/>
+            <a:ext cx="4754880" cy="457200"/>
           </a:xfrm>
           <a:prstGeom prst="rect">
             <a:avLst/>
@@ -4261,13 +4745,119 @@
           <a:p>
             <a:pPr algn="l"/>
             <a:r>
-              <a:rPr sz="1400" b="0">
+              <a:rPr sz="2200" b="1">
+                <a:solidFill>
+                  <a:srgbClr val="C45C26"/>
+                </a:solidFill>
+                <a:latin typeface="Microsoft YaHei"/>
+              </a:rPr>
+              <a:t>任务2</a:t>
+            </a:r>
+          </a:p>
+        </p:txBody>
+      </p:sp>
+      <p:sp>
+        <p:nvSpPr>
+          <p:cNvPr id="10" name="TextBox 9"/>
+          <p:cNvSpPr txBox="1"/>
+          <p:nvPr/>
+        </p:nvSpPr>
+        <p:spPr>
+          <a:xfrm>
+            <a:off x="6583680" y="2103120"/>
+            <a:ext cx="4754880" cy="2560320"/>
+          </a:xfrm>
+          <a:prstGeom prst="rect">
+            <a:avLst/>
+          </a:prstGeom>
+          <a:noFill/>
+        </p:spPr>
+        <p:txBody>
+          <a:bodyPr wrap="square">
+            <a:spAutoFit/>
+          </a:bodyPr>
+          <a:lstStyle/>
+          <a:p>
+            <a:pPr algn="l"/>
+            <a:r>
+              <a:rPr sz="2200" b="0">
+                <a:solidFill>
+                  <a:srgbClr val="1A3A4A"/>
+                </a:solidFill>
+                <a:latin typeface="Microsoft YaHei"/>
+              </a:rPr>
+              <a:t>分析共享单车中的数据传输</a:t>
+            </a:r>
+          </a:p>
+          <a:p>
+            <a:pPr algn="l"/>
+            <a:r>
+              <a:rPr sz="2200" b="0">
+                <a:solidFill>
+                  <a:srgbClr val="1A3A4A"/>
+                </a:solidFill>
+                <a:latin typeface="Microsoft YaHei"/>
+              </a:rPr>
+              <a:t/>
+            </a:r>
+          </a:p>
+          <a:p>
+            <a:pPr algn="l"/>
+            <a:r>
+              <a:rPr sz="2200" b="0">
+                <a:solidFill>
+                  <a:srgbClr val="1A3A4A"/>
+                </a:solidFill>
+                <a:latin typeface="Microsoft YaHei"/>
+              </a:rPr>
+              <a:t>找车 · 开锁 · 弱网补位</a:t>
+            </a:r>
+          </a:p>
+          <a:p>
+            <a:pPr algn="l"/>
+            <a:r>
+              <a:rPr sz="2200" b="0">
+                <a:solidFill>
+                  <a:srgbClr val="1A3A4A"/>
+                </a:solidFill>
+                <a:latin typeface="Microsoft YaHei"/>
+              </a:rPr>
+              <a:t>匹配 4G/5G · NB-IoT · 蓝牙</a:t>
+            </a:r>
+          </a:p>
+        </p:txBody>
+      </p:sp>
+      <p:sp>
+        <p:nvSpPr>
+          <p:cNvPr id="11" name="TextBox 10"/>
+          <p:cNvSpPr txBox="1"/>
+          <p:nvPr/>
+        </p:nvSpPr>
+        <p:spPr>
+          <a:xfrm>
+            <a:off x="457200" y="6446520"/>
+            <a:ext cx="11247120" cy="320040"/>
+          </a:xfrm>
+          <a:prstGeom prst="rect">
+            <a:avLst/>
+          </a:prstGeom>
+          <a:noFill/>
+        </p:spPr>
+        <p:txBody>
+          <a:bodyPr wrap="square">
+            <a:spAutoFit/>
+          </a:bodyPr>
+          <a:lstStyle/>
+          <a:p>
+            <a:pPr algn="l"/>
+            <a:r>
+              <a:rPr sz="1300" b="0">
                 <a:solidFill>
                   <a:srgbClr val="5A6A72"/>
                 </a:solidFill>
                 <a:latin typeface="Microsoft YaHei"/>
               </a:rPr>
-              <a:t>互动：用过共享单车的同学举手｜约2分钟</a:t>
+              <a:t>时间：任务1约4分钟｜任务2约11分钟｜小结+AI收束约5分钟</a:t>
             </a:r>
           </a:p>
         </p:txBody>
@@ -4305,7 +4895,7 @@
             <a:avLst/>
           </a:prstGeom>
           <a:solidFill>
-            <a:srgbClr val="F7F9FB"/>
+            <a:srgbClr val="F4F7F8"/>
           </a:solidFill>
           <a:ln>
             <a:noFill/>
@@ -4400,13 +4990,13 @@
           <a:p>
             <a:pPr algn="l"/>
             <a:r>
-              <a:rPr sz="3200" b="1">
+              <a:rPr sz="3400" b="1">
                 <a:solidFill>
                   <a:srgbClr val="1A3A4A"/>
                 </a:solidFill>
                 <a:latin typeface="Microsoft YaHei"/>
               </a:rPr>
-              <a:t>任务1：说一说共享单车的使用过程</a:t>
+              <a:t>AI助手“小青”登场</a:t>
             </a:r>
           </a:p>
         </p:txBody>
@@ -4419,14 +5009,14 @@
         </p:nvSpPr>
         <p:spPr>
           <a:xfrm>
-            <a:off x="548640" y="1280160"/>
-            <a:ext cx="3474720" cy="3474720"/>
+            <a:off x="548640" y="1188720"/>
+            <a:ext cx="10972800" cy="2011680"/>
           </a:xfrm>
           <a:prstGeom prst="roundRect">
             <a:avLst/>
           </a:prstGeom>
           <a:solidFill>
-            <a:srgbClr val="FFFFFF"/>
+            <a:srgbClr val="E6F3F1"/>
           </a:solidFill>
           <a:ln w="12700">
             <a:solidFill>
@@ -4464,8 +5054,8 @@
         </p:nvSpPr>
         <p:spPr>
           <a:xfrm>
-            <a:off x="777240" y="1554480"/>
-            <a:ext cx="3017520" cy="548640"/>
+            <a:off x="822960" y="1463040"/>
+            <a:ext cx="10424160" cy="1463040"/>
           </a:xfrm>
           <a:prstGeom prst="rect">
             <a:avLst/>
@@ -4480,13 +5070,25 @@
           <a:p>
             <a:pPr algn="l"/>
             <a:r>
-              <a:rPr sz="2800" b="1">
-                <a:solidFill>
-                  <a:srgbClr val="0D7A6F"/>
-                </a:solidFill>
-                <a:latin typeface="Microsoft YaHei"/>
-              </a:rPr>
-              <a:t>① 找车</a:t>
+              <a:rPr sz="2400" b="1">
+                <a:solidFill>
+                  <a:srgbClr val="1A3A4A"/>
+                </a:solidFill>
+                <a:latin typeface="Microsoft YaHei"/>
+              </a:rPr>
+              <a:t>老师问小青：共享单车是不是全都用 Wi-Fi 传数据就行？</a:t>
+            </a:r>
+          </a:p>
+          <a:p>
+            <a:pPr algn="l"/>
+            <a:r>
+              <a:rPr sz="2400" b="1">
+                <a:solidFill>
+                  <a:srgbClr val="1A3A4A"/>
+                </a:solidFill>
+                <a:latin typeface="Microsoft YaHei"/>
+              </a:rPr>
+              <a:t>（现场粘贴AI回答 / 或看第11页备援气泡）</a:t>
             </a:r>
           </a:p>
         </p:txBody>
@@ -4499,8 +5101,8 @@
         </p:nvSpPr>
         <p:spPr>
           <a:xfrm>
-            <a:off x="777240" y="2286000"/>
-            <a:ext cx="3017520" cy="1828800"/>
+            <a:off x="548640" y="3566160"/>
+            <a:ext cx="10972800" cy="2011680"/>
           </a:xfrm>
           <a:prstGeom prst="rect">
             <a:avLst/>
@@ -4515,96 +5117,51 @@
           <a:p>
             <a:pPr algn="l"/>
             <a:r>
-              <a:rPr sz="2000" b="0">
-                <a:solidFill>
-                  <a:srgbClr val="5A6A72"/>
-                </a:solidFill>
-                <a:latin typeface="Microsoft YaHei"/>
-              </a:rPr>
-              <a:t>（先听学生说）</a:t>
-            </a:r>
-          </a:p>
-          <a:p>
-            <a:pPr algn="l"/>
-            <a:r>
-              <a:rPr sz="2000" b="0">
-                <a:solidFill>
-                  <a:srgbClr val="5A6A72"/>
-                </a:solidFill>
-                <a:latin typeface="Microsoft YaHei"/>
-              </a:rPr>
-              <a:t/>
-            </a:r>
-          </a:p>
-          <a:p>
-            <a:pPr algn="l"/>
-            <a:r>
-              <a:rPr sz="2000" b="0">
-                <a:solidFill>
-                  <a:srgbClr val="5A6A72"/>
-                </a:solidFill>
-                <a:latin typeface="Microsoft YaHei"/>
-              </a:rPr>
-              <a:t>打开小程序，看见附近的车</a:t>
-            </a:r>
-          </a:p>
-        </p:txBody>
-      </p:sp>
-      <p:sp>
-        <p:nvSpPr>
-          <p:cNvPr id="8" name="Rounded Rectangle 7"/>
-          <p:cNvSpPr/>
-          <p:nvPr/>
-        </p:nvSpPr>
-        <p:spPr>
-          <a:xfrm>
-            <a:off x="4297679" y="1280160"/>
-            <a:ext cx="3474720" cy="3474720"/>
-          </a:xfrm>
-          <a:prstGeom prst="roundRect">
-            <a:avLst/>
-          </a:prstGeom>
-          <a:solidFill>
-            <a:srgbClr val="FFFFFF"/>
-          </a:solidFill>
-          <a:ln w="12700">
-            <a:solidFill>
-              <a:srgbClr val="D0DAE0"/>
-            </a:solidFill>
-          </a:ln>
-        </p:spPr>
-        <p:style>
-          <a:lnRef idx="1">
-            <a:schemeClr val="accent1"/>
-          </a:lnRef>
-          <a:fillRef idx="3">
-            <a:schemeClr val="accent1"/>
-          </a:fillRef>
-          <a:effectRef idx="2">
-            <a:schemeClr val="accent1"/>
-          </a:effectRef>
-          <a:fontRef idx="minor">
-            <a:schemeClr val="lt1"/>
-          </a:fontRef>
-        </p:style>
-        <p:txBody>
-          <a:bodyPr rtlCol="0" anchor="ctr"/>
-          <a:lstStyle/>
-          <a:p>
-            <a:pPr algn="ctr"/>
-          </a:p>
-        </p:txBody>
-      </p:sp>
-      <p:sp>
-        <p:nvSpPr>
-          <p:cNvPr id="9" name="TextBox 8"/>
+              <a:rPr sz="2200" b="0">
+                <a:solidFill>
+                  <a:srgbClr val="1A3A4A"/>
+                </a:solidFill>
+                <a:latin typeface="Microsoft YaHei"/>
+              </a:rPr>
+              <a:t>课堂规则：</a:t>
+            </a:r>
+          </a:p>
+          <a:p>
+            <a:pPr algn="l"/>
+            <a:r>
+              <a:rPr sz="2200" b="0">
+                <a:solidFill>
+                  <a:srgbClr val="1A3A4A"/>
+                </a:solidFill>
+                <a:latin typeface="Microsoft YaHei"/>
+              </a:rPr>
+              <a:t>1. 小青可以发言，但不是标准答案</a:t>
+            </a:r>
+          </a:p>
+          <a:p>
+            <a:pPr algn="l"/>
+            <a:r>
+              <a:rPr sz="2200" b="0">
+                <a:solidFill>
+                  <a:srgbClr val="1A3A4A"/>
+                </a:solidFill>
+                <a:latin typeface="Microsoft YaHei"/>
+              </a:rPr>
+              <a:t>2. 下课前，用今天的分析判断：它说得对，还是不完整？</a:t>
+            </a:r>
+          </a:p>
+        </p:txBody>
+      </p:sp>
+      <p:sp>
+        <p:nvSpPr>
+          <p:cNvPr id="8" name="TextBox 7"/>
           <p:cNvSpPr txBox="1"/>
           <p:nvPr/>
         </p:nvSpPr>
         <p:spPr>
           <a:xfrm>
-            <a:off x="4526279" y="1554480"/>
-            <a:ext cx="3017520" cy="548640"/>
+            <a:off x="457200" y="6446520"/>
+            <a:ext cx="11247120" cy="320040"/>
           </a:xfrm>
           <a:prstGeom prst="rect">
             <a:avLst/>
@@ -4619,246 +5176,13 @@
           <a:p>
             <a:pPr algn="l"/>
             <a:r>
-              <a:rPr sz="2800" b="1">
-                <a:solidFill>
-                  <a:srgbClr val="0D7A6F"/>
-                </a:solidFill>
-                <a:latin typeface="Microsoft YaHei"/>
-              </a:rPr>
-              <a:t>② 开锁</a:t>
-            </a:r>
-          </a:p>
-        </p:txBody>
-      </p:sp>
-      <p:sp>
-        <p:nvSpPr>
-          <p:cNvPr id="10" name="TextBox 9"/>
-          <p:cNvSpPr txBox="1"/>
-          <p:nvPr/>
-        </p:nvSpPr>
-        <p:spPr>
-          <a:xfrm>
-            <a:off x="4526279" y="2286000"/>
-            <a:ext cx="3017520" cy="1828800"/>
-          </a:xfrm>
-          <a:prstGeom prst="rect">
-            <a:avLst/>
-          </a:prstGeom>
-          <a:noFill/>
-        </p:spPr>
-        <p:txBody>
-          <a:bodyPr wrap="square">
-            <a:spAutoFit/>
-          </a:bodyPr>
-          <a:lstStyle/>
-          <a:p>
-            <a:pPr algn="l"/>
-            <a:r>
-              <a:rPr sz="2000" b="0">
+              <a:rPr sz="1300" b="0">
                 <a:solidFill>
                   <a:srgbClr val="5A6A72"/>
                 </a:solidFill>
                 <a:latin typeface="Microsoft YaHei"/>
               </a:rPr>
-              <a:t>（先听学生说）</a:t>
-            </a:r>
-          </a:p>
-          <a:p>
-            <a:pPr algn="l"/>
-            <a:r>
-              <a:rPr sz="2000" b="0">
-                <a:solidFill>
-                  <a:srgbClr val="5A6A72"/>
-                </a:solidFill>
-                <a:latin typeface="Microsoft YaHei"/>
-              </a:rPr>
-              <a:t/>
-            </a:r>
-          </a:p>
-          <a:p>
-            <a:pPr algn="l"/>
-            <a:r>
-              <a:rPr sz="2000" b="0">
-                <a:solidFill>
-                  <a:srgbClr val="5A6A72"/>
-                </a:solidFill>
-                <a:latin typeface="Microsoft YaHei"/>
-              </a:rPr>
-              <a:t>扫码，车锁打开</a:t>
-            </a:r>
-          </a:p>
-        </p:txBody>
-      </p:sp>
-      <p:sp>
-        <p:nvSpPr>
-          <p:cNvPr id="11" name="Rounded Rectangle 10"/>
-          <p:cNvSpPr/>
-          <p:nvPr/>
-        </p:nvSpPr>
-        <p:spPr>
-          <a:xfrm>
-            <a:off x="8046719" y="1280160"/>
-            <a:ext cx="3474720" cy="3474720"/>
-          </a:xfrm>
-          <a:prstGeom prst="roundRect">
-            <a:avLst/>
-          </a:prstGeom>
-          <a:solidFill>
-            <a:srgbClr val="FFFFFF"/>
-          </a:solidFill>
-          <a:ln w="12700">
-            <a:solidFill>
-              <a:srgbClr val="D0DAE0"/>
-            </a:solidFill>
-          </a:ln>
-        </p:spPr>
-        <p:style>
-          <a:lnRef idx="1">
-            <a:schemeClr val="accent1"/>
-          </a:lnRef>
-          <a:fillRef idx="3">
-            <a:schemeClr val="accent1"/>
-          </a:fillRef>
-          <a:effectRef idx="2">
-            <a:schemeClr val="accent1"/>
-          </a:effectRef>
-          <a:fontRef idx="minor">
-            <a:schemeClr val="lt1"/>
-          </a:fontRef>
-        </p:style>
-        <p:txBody>
-          <a:bodyPr rtlCol="0" anchor="ctr"/>
-          <a:lstStyle/>
-          <a:p>
-            <a:pPr algn="ctr"/>
-          </a:p>
-        </p:txBody>
-      </p:sp>
-      <p:sp>
-        <p:nvSpPr>
-          <p:cNvPr id="12" name="TextBox 11"/>
-          <p:cNvSpPr txBox="1"/>
-          <p:nvPr/>
-        </p:nvSpPr>
-        <p:spPr>
-          <a:xfrm>
-            <a:off x="8275319" y="1554480"/>
-            <a:ext cx="3017520" cy="548640"/>
-          </a:xfrm>
-          <a:prstGeom prst="rect">
-            <a:avLst/>
-          </a:prstGeom>
-          <a:noFill/>
-        </p:spPr>
-        <p:txBody>
-          <a:bodyPr wrap="square">
-            <a:spAutoFit/>
-          </a:bodyPr>
-          <a:lstStyle/>
-          <a:p>
-            <a:pPr algn="l"/>
-            <a:r>
-              <a:rPr sz="2800" b="1">
-                <a:solidFill>
-                  <a:srgbClr val="0D7A6F"/>
-                </a:solidFill>
-                <a:latin typeface="Microsoft YaHei"/>
-              </a:rPr>
-              <a:t>③ 骑行</a:t>
-            </a:r>
-          </a:p>
-        </p:txBody>
-      </p:sp>
-      <p:sp>
-        <p:nvSpPr>
-          <p:cNvPr id="13" name="TextBox 12"/>
-          <p:cNvSpPr txBox="1"/>
-          <p:nvPr/>
-        </p:nvSpPr>
-        <p:spPr>
-          <a:xfrm>
-            <a:off x="8275319" y="2286000"/>
-            <a:ext cx="3017520" cy="1828800"/>
-          </a:xfrm>
-          <a:prstGeom prst="rect">
-            <a:avLst/>
-          </a:prstGeom>
-          <a:noFill/>
-        </p:spPr>
-        <p:txBody>
-          <a:bodyPr wrap="square">
-            <a:spAutoFit/>
-          </a:bodyPr>
-          <a:lstStyle/>
-          <a:p>
-            <a:pPr algn="l"/>
-            <a:r>
-              <a:rPr sz="2000" b="0">
-                <a:solidFill>
-                  <a:srgbClr val="5A6A72"/>
-                </a:solidFill>
-                <a:latin typeface="Microsoft YaHei"/>
-              </a:rPr>
-              <a:t>（先听学生说）</a:t>
-            </a:r>
-          </a:p>
-          <a:p>
-            <a:pPr algn="l"/>
-            <a:r>
-              <a:rPr sz="2000" b="0">
-                <a:solidFill>
-                  <a:srgbClr val="5A6A72"/>
-                </a:solidFill>
-                <a:latin typeface="Microsoft YaHei"/>
-              </a:rPr>
-              <a:t/>
-            </a:r>
-          </a:p>
-          <a:p>
-            <a:pPr algn="l"/>
-            <a:r>
-              <a:rPr sz="2000" b="0">
-                <a:solidFill>
-                  <a:srgbClr val="5A6A72"/>
-                </a:solidFill>
-                <a:latin typeface="Microsoft YaHei"/>
-              </a:rPr>
-              <a:t>骑走，到达后还车</a:t>
-            </a:r>
-          </a:p>
-        </p:txBody>
-      </p:sp>
-      <p:sp>
-        <p:nvSpPr>
-          <p:cNvPr id="14" name="TextBox 13"/>
-          <p:cNvSpPr txBox="1"/>
-          <p:nvPr/>
-        </p:nvSpPr>
-        <p:spPr>
-          <a:xfrm>
-            <a:off x="457200" y="6446520"/>
-            <a:ext cx="10972800" cy="320040"/>
-          </a:xfrm>
-          <a:prstGeom prst="rect">
-            <a:avLst/>
-          </a:prstGeom>
-          <a:noFill/>
-        </p:spPr>
-        <p:txBody>
-          <a:bodyPr wrap="square">
-            <a:spAutoFit/>
-          </a:bodyPr>
-          <a:lstStyle/>
-          <a:p>
-            <a:pPr algn="l"/>
-            <a:r>
-              <a:rPr sz="1400" b="0">
-                <a:solidFill>
-                  <a:srgbClr val="5A6A72"/>
-                </a:solidFill>
-                <a:latin typeface="Microsoft YaHei"/>
-              </a:rPr>
-              <a:t>同桌商量10秒 → 请1位说，其他人补充｜先说生活，不说技术</a:t>
+              <a:t>AI-1 钩子｜约40秒｜失败则切第11页</a:t>
             </a:r>
           </a:p>
         </p:txBody>
@@ -4896,7 +5220,7 @@
             <a:avLst/>
           </a:prstGeom>
           <a:solidFill>
-            <a:srgbClr val="F7F9FB"/>
+            <a:srgbClr val="F4F7F8"/>
           </a:solidFill>
           <a:ln>
             <a:noFill/>
@@ -4975,8 +5299,8 @@
         </p:nvSpPr>
         <p:spPr>
           <a:xfrm>
-            <a:off x="548640" y="320040"/>
-            <a:ext cx="10972800" cy="548640"/>
+            <a:off x="548640" y="274320"/>
+            <a:ext cx="10972800" cy="502920"/>
           </a:xfrm>
           <a:prstGeom prst="rect">
             <a:avLst/>
@@ -4997,7 +5321,7 @@
                 </a:solidFill>
                 <a:latin typeface="Microsoft YaHei"/>
               </a:rPr>
-              <a:t>数据在“旅行”：先找路径，暂不命名技术</a:t>
+              <a:t>任务1：把使用过程排正确（25秒）</a:t>
             </a:r>
           </a:p>
         </p:txBody>
@@ -5010,14 +5334,14 @@
         </p:nvSpPr>
         <p:spPr>
           <a:xfrm>
-            <a:off x="731520" y="2286000"/>
-            <a:ext cx="2926080" cy="1828800"/>
+            <a:off x="502920" y="1188720"/>
+            <a:ext cx="2743200" cy="3200400"/>
           </a:xfrm>
           <a:prstGeom prst="roundRect">
             <a:avLst/>
           </a:prstGeom>
           <a:solidFill>
-            <a:srgbClr val="E6F3F1"/>
+            <a:srgbClr val="FFFFFF"/>
           </a:solidFill>
           <a:ln w="12700">
             <a:solidFill>
@@ -5055,8 +5379,8 @@
         </p:nvSpPr>
         <p:spPr>
           <a:xfrm>
-            <a:off x="914400" y="2834640"/>
-            <a:ext cx="2560320" cy="731520"/>
+            <a:off x="640080" y="1463040"/>
+            <a:ext cx="2468880" cy="457200"/>
           </a:xfrm>
           <a:prstGeom prst="rect">
             <a:avLst/>
@@ -5071,33 +5395,68 @@
           <a:p>
             <a:pPr algn="ctr"/>
             <a:r>
-              <a:rPr sz="2400" b="1">
+              <a:rPr sz="1800" b="0">
+                <a:solidFill>
+                  <a:srgbClr val="5A6A72"/>
+                </a:solidFill>
+                <a:latin typeface="Microsoft YaHei"/>
+              </a:rPr>
+              <a:t>卡片 A</a:t>
+            </a:r>
+          </a:p>
+        </p:txBody>
+      </p:sp>
+      <p:sp>
+        <p:nvSpPr>
+          <p:cNvPr id="7" name="TextBox 6"/>
+          <p:cNvSpPr txBox="1"/>
+          <p:nvPr/>
+        </p:nvSpPr>
+        <p:spPr>
+          <a:xfrm>
+            <a:off x="640080" y="2286000"/>
+            <a:ext cx="2468880" cy="1371600"/>
+          </a:xfrm>
+          <a:prstGeom prst="rect">
+            <a:avLst/>
+          </a:prstGeom>
+          <a:noFill/>
+        </p:spPr>
+        <p:txBody>
+          <a:bodyPr wrap="square">
+            <a:spAutoFit/>
+          </a:bodyPr>
+          <a:lstStyle/>
+          <a:p>
+            <a:pPr algn="ctr"/>
+            <a:r>
+              <a:rPr sz="2600" b="1">
                 <a:solidFill>
                   <a:srgbClr val="1A3A4A"/>
                 </a:solidFill>
                 <a:latin typeface="Microsoft YaHei"/>
               </a:rPr>
-              <a:t>手机/小程序</a:t>
-            </a:r>
-          </a:p>
-        </p:txBody>
-      </p:sp>
-      <p:sp>
-        <p:nvSpPr>
-          <p:cNvPr id="7" name="Rounded Rectangle 6"/>
+              <a:t>扫码</a:t>
+            </a:r>
+          </a:p>
+        </p:txBody>
+      </p:sp>
+      <p:sp>
+        <p:nvSpPr>
+          <p:cNvPr id="8" name="Rounded Rectangle 7"/>
           <p:cNvSpPr/>
           <p:nvPr/>
         </p:nvSpPr>
         <p:spPr>
           <a:xfrm>
-            <a:off x="4572000" y="2286000"/>
-            <a:ext cx="2926080" cy="1828800"/>
+            <a:off x="3383280" y="1188720"/>
+            <a:ext cx="2743200" cy="3200400"/>
           </a:xfrm>
           <a:prstGeom prst="roundRect">
             <a:avLst/>
           </a:prstGeom>
           <a:solidFill>
-            <a:srgbClr val="E6F3F1"/>
+            <a:srgbClr val="FFFFFF"/>
           </a:solidFill>
           <a:ln w="12700">
             <a:solidFill>
@@ -5129,14 +5488,14 @@
       </p:sp>
       <p:sp>
         <p:nvSpPr>
-          <p:cNvPr id="8" name="TextBox 7"/>
+          <p:cNvPr id="9" name="TextBox 8"/>
           <p:cNvSpPr txBox="1"/>
           <p:nvPr/>
         </p:nvSpPr>
         <p:spPr>
           <a:xfrm>
-            <a:off x="4754880" y="2834640"/>
-            <a:ext cx="2560320" cy="731520"/>
+            <a:off x="3520440" y="1463040"/>
+            <a:ext cx="2468880" cy="457200"/>
           </a:xfrm>
           <a:prstGeom prst="rect">
             <a:avLst/>
@@ -5151,33 +5510,68 @@
           <a:p>
             <a:pPr algn="ctr"/>
             <a:r>
-              <a:rPr sz="2400" b="1">
+              <a:rPr sz="1800" b="0">
+                <a:solidFill>
+                  <a:srgbClr val="5A6A72"/>
+                </a:solidFill>
+                <a:latin typeface="Microsoft YaHei"/>
+              </a:rPr>
+              <a:t>卡片 B</a:t>
+            </a:r>
+          </a:p>
+        </p:txBody>
+      </p:sp>
+      <p:sp>
+        <p:nvSpPr>
+          <p:cNvPr id="10" name="TextBox 9"/>
+          <p:cNvSpPr txBox="1"/>
+          <p:nvPr/>
+        </p:nvSpPr>
+        <p:spPr>
+          <a:xfrm>
+            <a:off x="3520440" y="2286000"/>
+            <a:ext cx="2468880" cy="1371600"/>
+          </a:xfrm>
+          <a:prstGeom prst="rect">
+            <a:avLst/>
+          </a:prstGeom>
+          <a:noFill/>
+        </p:spPr>
+        <p:txBody>
+          <a:bodyPr wrap="square">
+            <a:spAutoFit/>
+          </a:bodyPr>
+          <a:lstStyle/>
+          <a:p>
+            <a:pPr algn="ctr"/>
+            <a:r>
+              <a:rPr sz="2600" b="1">
                 <a:solidFill>
                   <a:srgbClr val="1A3A4A"/>
                 </a:solidFill>
                 <a:latin typeface="Microsoft YaHei"/>
               </a:rPr>
-              <a:t>服务器/云端</a:t>
-            </a:r>
-          </a:p>
-        </p:txBody>
-      </p:sp>
-      <p:sp>
-        <p:nvSpPr>
-          <p:cNvPr id="9" name="Rounded Rectangle 8"/>
+              <a:t>打开小程序</a:t>
+            </a:r>
+          </a:p>
+        </p:txBody>
+      </p:sp>
+      <p:sp>
+        <p:nvSpPr>
+          <p:cNvPr id="11" name="Rounded Rectangle 10"/>
           <p:cNvSpPr/>
           <p:nvPr/>
         </p:nvSpPr>
         <p:spPr>
           <a:xfrm>
-            <a:off x="8412480" y="2286000"/>
-            <a:ext cx="2926080" cy="1828800"/>
+            <a:off x="6263640" y="1188720"/>
+            <a:ext cx="2743200" cy="3200400"/>
           </a:xfrm>
           <a:prstGeom prst="roundRect">
             <a:avLst/>
           </a:prstGeom>
           <a:solidFill>
-            <a:srgbClr val="E6F3F1"/>
+            <a:srgbClr val="FFFFFF"/>
           </a:solidFill>
           <a:ln w="12700">
             <a:solidFill>
@@ -5209,14 +5603,14 @@
       </p:sp>
       <p:sp>
         <p:nvSpPr>
-          <p:cNvPr id="10" name="TextBox 9"/>
+          <p:cNvPr id="12" name="TextBox 11"/>
           <p:cNvSpPr txBox="1"/>
           <p:nvPr/>
         </p:nvSpPr>
         <p:spPr>
           <a:xfrm>
-            <a:off x="8595360" y="2834640"/>
-            <a:ext cx="2560320" cy="731520"/>
+            <a:off x="6400800" y="1463040"/>
+            <a:ext cx="2468880" cy="457200"/>
           </a:xfrm>
           <a:prstGeom prst="rect">
             <a:avLst/>
@@ -5231,27 +5625,27 @@
           <a:p>
             <a:pPr algn="ctr"/>
             <a:r>
-              <a:rPr sz="2400" b="1">
-                <a:solidFill>
-                  <a:srgbClr val="1A3A4A"/>
-                </a:solidFill>
-                <a:latin typeface="Microsoft YaHei"/>
-              </a:rPr>
-              <a:t>共享单车</a:t>
-            </a:r>
-          </a:p>
-        </p:txBody>
-      </p:sp>
-      <p:sp>
-        <p:nvSpPr>
-          <p:cNvPr id="11" name="TextBox 10"/>
+              <a:rPr sz="1800" b="0">
+                <a:solidFill>
+                  <a:srgbClr val="5A6A72"/>
+                </a:solidFill>
+                <a:latin typeface="Microsoft YaHei"/>
+              </a:rPr>
+              <a:t>卡片 C</a:t>
+            </a:r>
+          </a:p>
+        </p:txBody>
+      </p:sp>
+      <p:sp>
+        <p:nvSpPr>
+          <p:cNvPr id="13" name="TextBox 12"/>
           <p:cNvSpPr txBox="1"/>
           <p:nvPr/>
         </p:nvSpPr>
         <p:spPr>
           <a:xfrm>
-            <a:off x="548640" y="4754880"/>
-            <a:ext cx="10972800" cy="1097280"/>
+            <a:off x="6400800" y="2286000"/>
+            <a:ext cx="2468880" cy="1371600"/>
           </a:xfrm>
           <a:prstGeom prst="rect">
             <a:avLst/>
@@ -5264,41 +5658,74 @@
           </a:bodyPr>
           <a:lstStyle/>
           <a:p>
-            <a:pPr algn="l"/>
-            <a:r>
-              <a:rPr sz="2200" b="0">
+            <a:pPr algn="ctr"/>
+            <a:r>
+              <a:rPr sz="2600" b="1">
                 <a:solidFill>
                   <a:srgbClr val="1A3A4A"/>
                 </a:solidFill>
                 <a:latin typeface="Microsoft YaHei"/>
               </a:rPr>
-              <a:t>想一想：找车时，数据可能在哪几条线上流动？</a:t>
-            </a:r>
-          </a:p>
-          <a:p>
-            <a:pPr algn="l"/>
-            <a:r>
-              <a:rPr sz="2200" b="0">
-                <a:solidFill>
-                  <a:srgbClr val="1A3A4A"/>
-                </a:solidFill>
-                <a:latin typeface="Microsoft YaHei"/>
-              </a:rPr>
-              <a:t>用手指比划：手机 ↔ 服务器 ↔ 单车</a:t>
-            </a:r>
-          </a:p>
-        </p:txBody>
-      </p:sp>
-      <p:sp>
-        <p:nvSpPr>
-          <p:cNvPr id="12" name="TextBox 11"/>
+              <a:t>开锁骑走</a:t>
+            </a:r>
+          </a:p>
+        </p:txBody>
+      </p:sp>
+      <p:sp>
+        <p:nvSpPr>
+          <p:cNvPr id="14" name="Rounded Rectangle 13"/>
+          <p:cNvSpPr/>
+          <p:nvPr/>
+        </p:nvSpPr>
+        <p:spPr>
+          <a:xfrm>
+            <a:off x="9144000" y="1188720"/>
+            <a:ext cx="2743200" cy="3200400"/>
+          </a:xfrm>
+          <a:prstGeom prst="roundRect">
+            <a:avLst/>
+          </a:prstGeom>
+          <a:solidFill>
+            <a:srgbClr val="FFFFFF"/>
+          </a:solidFill>
+          <a:ln w="12700">
+            <a:solidFill>
+              <a:srgbClr val="D0DAE0"/>
+            </a:solidFill>
+          </a:ln>
+        </p:spPr>
+        <p:style>
+          <a:lnRef idx="1">
+            <a:schemeClr val="accent1"/>
+          </a:lnRef>
+          <a:fillRef idx="3">
+            <a:schemeClr val="accent1"/>
+          </a:fillRef>
+          <a:effectRef idx="2">
+            <a:schemeClr val="accent1"/>
+          </a:effectRef>
+          <a:fontRef idx="minor">
+            <a:schemeClr val="lt1"/>
+          </a:fontRef>
+        </p:style>
+        <p:txBody>
+          <a:bodyPr rtlCol="0" anchor="ctr"/>
+          <a:lstStyle/>
+          <a:p>
+            <a:pPr algn="ctr"/>
+          </a:p>
+        </p:txBody>
+      </p:sp>
+      <p:sp>
+        <p:nvSpPr>
+          <p:cNvPr id="15" name="TextBox 14"/>
           <p:cNvSpPr txBox="1"/>
           <p:nvPr/>
         </p:nvSpPr>
         <p:spPr>
           <a:xfrm>
-            <a:off x="457200" y="6446520"/>
-            <a:ext cx="10972800" cy="320040"/>
+            <a:off x="9281160" y="1463040"/>
+            <a:ext cx="2468880" cy="457200"/>
           </a:xfrm>
           <a:prstGeom prst="rect">
             <a:avLst/>
@@ -5311,15 +5738,132 @@
           </a:bodyPr>
           <a:lstStyle/>
           <a:p>
-            <a:pPr algn="l"/>
-            <a:r>
-              <a:rPr sz="1400" b="0">
+            <a:pPr algn="ctr"/>
+            <a:r>
+              <a:rPr sz="1800" b="0">
                 <a:solidFill>
                   <a:srgbClr val="5A6A72"/>
                 </a:solidFill>
                 <a:latin typeface="Microsoft YaHei"/>
               </a:rPr>
-              <a:t>同桌指图20秒｜抽2人各说一句</a:t>
+              <a:t>卡片 D</a:t>
+            </a:r>
+          </a:p>
+        </p:txBody>
+      </p:sp>
+      <p:sp>
+        <p:nvSpPr>
+          <p:cNvPr id="16" name="TextBox 15"/>
+          <p:cNvSpPr txBox="1"/>
+          <p:nvPr/>
+        </p:nvSpPr>
+        <p:spPr>
+          <a:xfrm>
+            <a:off x="9281160" y="2286000"/>
+            <a:ext cx="2468880" cy="1371600"/>
+          </a:xfrm>
+          <a:prstGeom prst="rect">
+            <a:avLst/>
+          </a:prstGeom>
+          <a:noFill/>
+        </p:spPr>
+        <p:txBody>
+          <a:bodyPr wrap="square">
+            <a:spAutoFit/>
+          </a:bodyPr>
+          <a:lstStyle/>
+          <a:p>
+            <a:pPr algn="ctr"/>
+            <a:r>
+              <a:rPr sz="2600" b="1">
+                <a:solidFill>
+                  <a:srgbClr val="1A3A4A"/>
+                </a:solidFill>
+                <a:latin typeface="Microsoft YaHei"/>
+              </a:rPr>
+              <a:t>看到附近的车</a:t>
+            </a:r>
+          </a:p>
+        </p:txBody>
+      </p:sp>
+      <p:sp>
+        <p:nvSpPr>
+          <p:cNvPr id="17" name="TextBox 16"/>
+          <p:cNvSpPr txBox="1"/>
+          <p:nvPr/>
+        </p:nvSpPr>
+        <p:spPr>
+          <a:xfrm>
+            <a:off x="548640" y="4754880"/>
+            <a:ext cx="10972800" cy="1097280"/>
+          </a:xfrm>
+          <a:prstGeom prst="rect">
+            <a:avLst/>
+          </a:prstGeom>
+          <a:noFill/>
+        </p:spPr>
+        <p:txBody>
+          <a:bodyPr wrap="square">
+            <a:spAutoFit/>
+          </a:bodyPr>
+          <a:lstStyle/>
+          <a:p>
+            <a:pPr algn="l"/>
+            <a:r>
+              <a:rPr sz="2200" b="0">
+                <a:solidFill>
+                  <a:srgbClr val="0D7A6F"/>
+                </a:solidFill>
+                <a:latin typeface="Microsoft YaHei"/>
+              </a:rPr>
+              <a:t>揭晓顺序：B → D → A → C</a:t>
+            </a:r>
+          </a:p>
+          <a:p>
+            <a:pPr algn="l"/>
+            <a:r>
+              <a:rPr sz="2200" b="0">
+                <a:solidFill>
+                  <a:srgbClr val="0D7A6F"/>
+                </a:solidFill>
+                <a:latin typeface="Microsoft YaHei"/>
+              </a:rPr>
+              <a:t>打开小程序 → 看到附近的车 → 扫码 → 开锁骑走</a:t>
+            </a:r>
+          </a:p>
+        </p:txBody>
+      </p:sp>
+      <p:sp>
+        <p:nvSpPr>
+          <p:cNvPr id="18" name="TextBox 17"/>
+          <p:cNvSpPr txBox="1"/>
+          <p:nvPr/>
+        </p:nvSpPr>
+        <p:spPr>
+          <a:xfrm>
+            <a:off x="457200" y="6446520"/>
+            <a:ext cx="11247120" cy="320040"/>
+          </a:xfrm>
+          <a:prstGeom prst="rect">
+            <a:avLst/>
+          </a:prstGeom>
+          <a:noFill/>
+        </p:spPr>
+        <p:txBody>
+          <a:bodyPr wrap="square">
+            <a:spAutoFit/>
+          </a:bodyPr>
+          <a:lstStyle/>
+          <a:p>
+            <a:pPr algn="l"/>
+            <a:r>
+              <a:rPr sz="1300" b="0">
+                <a:solidFill>
+                  <a:srgbClr val="5A6A72"/>
+                </a:solidFill>
+                <a:latin typeface="Microsoft YaHei"/>
+              </a:rPr>
+              <a:t>同桌排序｜抽1组报序｜任务1必须在5:30前结束</a:t>
             </a:r>
           </a:p>
         </p:txBody>
@@ -5357,7 +5901,7 @@
             <a:avLst/>
           </a:prstGeom>
           <a:solidFill>
-            <a:srgbClr val="F7F9FB"/>
+            <a:srgbClr val="F4F7F8"/>
           </a:solidFill>
           <a:ln>
             <a:noFill/>
@@ -5437,7 +5981,7 @@
         <p:spPr>
           <a:xfrm>
             <a:off x="548640" y="320040"/>
-            <a:ext cx="10972800" cy="548640"/>
+            <a:ext cx="10972800" cy="502920"/>
           </a:xfrm>
           <a:prstGeom prst="rect">
             <a:avLst/>
@@ -5458,7 +6002,7 @@
                 </a:solidFill>
                 <a:latin typeface="Microsoft YaHei"/>
               </a:rPr>
-              <a:t>任务2·情境A：小程序怎么知道车在哪？</a:t>
+              <a:t>任务1收口：数据在谁和谁之间流动？</a:t>
             </a:r>
           </a:p>
         </p:txBody>
@@ -5471,14 +6015,14 @@
         </p:nvSpPr>
         <p:spPr>
           <a:xfrm>
-            <a:off x="548640" y="1188720"/>
-            <a:ext cx="5303520" cy="4114800"/>
+            <a:off x="731520" y="2103120"/>
+            <a:ext cx="2926080" cy="1828800"/>
           </a:xfrm>
           <a:prstGeom prst="roundRect">
             <a:avLst/>
           </a:prstGeom>
           <a:solidFill>
-            <a:srgbClr val="FFFFFF"/>
+            <a:srgbClr val="E6F3F1"/>
           </a:solidFill>
           <a:ln w="12700">
             <a:solidFill>
@@ -5516,8 +6060,8 @@
         </p:nvSpPr>
         <p:spPr>
           <a:xfrm>
-            <a:off x="822960" y="1463040"/>
-            <a:ext cx="4754880" cy="457200"/>
+            <a:off x="868680" y="2651760"/>
+            <a:ext cx="2651760" cy="731520"/>
           </a:xfrm>
           <a:prstGeom prst="rect">
             <a:avLst/>
@@ -5530,118 +6074,35 @@
           </a:bodyPr>
           <a:lstStyle/>
           <a:p>
-            <a:pPr algn="l"/>
+            <a:pPr algn="ctr"/>
             <a:r>
               <a:rPr sz="2400" b="1">
                 <a:solidFill>
-                  <a:srgbClr val="0D7A6F"/>
-                </a:solidFill>
-                <a:latin typeface="Microsoft YaHei"/>
-              </a:rPr>
-              <a:t>手机这一端</a:t>
-            </a:r>
-          </a:p>
-        </p:txBody>
-      </p:sp>
-      <p:sp>
-        <p:nvSpPr>
-          <p:cNvPr id="7" name="TextBox 6"/>
-          <p:cNvSpPr txBox="1"/>
-          <p:nvPr/>
-        </p:nvSpPr>
-        <p:spPr>
-          <a:xfrm>
-            <a:off x="822960" y="2194560"/>
-            <a:ext cx="4754880" cy="2560320"/>
-          </a:xfrm>
-          <a:prstGeom prst="rect">
-            <a:avLst/>
-          </a:prstGeom>
-          <a:noFill/>
-        </p:spPr>
-        <p:txBody>
-          <a:bodyPr wrap="square">
-            <a:spAutoFit/>
-          </a:bodyPr>
-          <a:lstStyle/>
-          <a:p>
-            <a:pPr algn="l"/>
-            <a:r>
-              <a:rPr sz="2200" b="0">
-                <a:solidFill>
                   <a:srgbClr val="1A3A4A"/>
                 </a:solidFill>
                 <a:latin typeface="Microsoft YaHei"/>
               </a:rPr>
-              <a:t>投票：手机连什么网更合理？</a:t>
-            </a:r>
-          </a:p>
-          <a:p>
-            <a:pPr algn="l"/>
-            <a:r>
-              <a:rPr sz="2200" b="0">
-                <a:solidFill>
-                  <a:srgbClr val="1A3A4A"/>
-                </a:solidFill>
-                <a:latin typeface="Microsoft YaHei"/>
-              </a:rPr>
-              <a:t/>
-            </a:r>
-          </a:p>
-          <a:p>
-            <a:pPr algn="l"/>
-            <a:r>
-              <a:rPr sz="2200" b="0">
-                <a:solidFill>
-                  <a:srgbClr val="1A3A4A"/>
-                </a:solidFill>
-                <a:latin typeface="Microsoft YaHei"/>
-              </a:rPr>
-              <a:t>A. 只用教室Wi-Fi</a:t>
-            </a:r>
-          </a:p>
-          <a:p>
-            <a:pPr algn="l"/>
-            <a:r>
-              <a:rPr sz="2200" b="0">
-                <a:solidFill>
-                  <a:srgbClr val="1A3A4A"/>
-                </a:solidFill>
-                <a:latin typeface="Microsoft YaHei"/>
-              </a:rPr>
-              <a:t>B. 4G/5G移动网络</a:t>
-            </a:r>
-          </a:p>
-          <a:p>
-            <a:pPr algn="l"/>
-            <a:r>
-              <a:rPr sz="2200" b="0">
-                <a:solidFill>
-                  <a:srgbClr val="1A3A4A"/>
-                </a:solidFill>
-                <a:latin typeface="Microsoft YaHei"/>
-              </a:rPr>
-              <a:t>C. 必须插网线</a:t>
-            </a:r>
-          </a:p>
-        </p:txBody>
-      </p:sp>
-      <p:sp>
-        <p:nvSpPr>
-          <p:cNvPr id="8" name="Rounded Rectangle 7"/>
+              <a:t>手机/小程序</a:t>
+            </a:r>
+          </a:p>
+        </p:txBody>
+      </p:sp>
+      <p:sp>
+        <p:nvSpPr>
+          <p:cNvPr id="7" name="Rounded Rectangle 6"/>
           <p:cNvSpPr/>
           <p:nvPr/>
         </p:nvSpPr>
         <p:spPr>
           <a:xfrm>
-            <a:off x="6309360" y="1188720"/>
-            <a:ext cx="5303520" cy="4114800"/>
+            <a:off x="4572000" y="2103120"/>
+            <a:ext cx="2926080" cy="1828800"/>
           </a:xfrm>
           <a:prstGeom prst="roundRect">
             <a:avLst/>
           </a:prstGeom>
           <a:solidFill>
-            <a:srgbClr val="FFFFFF"/>
+            <a:srgbClr val="E6F3F1"/>
           </a:solidFill>
           <a:ln w="12700">
             <a:solidFill>
@@ -5673,14 +6134,14 @@
       </p:sp>
       <p:sp>
         <p:nvSpPr>
-          <p:cNvPr id="9" name="TextBox 8"/>
+          <p:cNvPr id="8" name="TextBox 7"/>
           <p:cNvSpPr txBox="1"/>
           <p:nvPr/>
         </p:nvSpPr>
         <p:spPr>
           <a:xfrm>
-            <a:off x="6583680" y="1463040"/>
-            <a:ext cx="4754880" cy="457200"/>
+            <a:off x="4709160" y="2651760"/>
+            <a:ext cx="2651760" cy="731520"/>
           </a:xfrm>
           <a:prstGeom prst="rect">
             <a:avLst/>
@@ -5693,16 +6154,61 @@
           </a:bodyPr>
           <a:lstStyle/>
           <a:p>
-            <a:pPr algn="l"/>
+            <a:pPr algn="ctr"/>
             <a:r>
               <a:rPr sz="2400" b="1">
                 <a:solidFill>
-                  <a:srgbClr val="C45C26"/>
-                </a:solidFill>
-                <a:latin typeface="Microsoft YaHei"/>
-              </a:rPr>
-              <a:t>单车这一端</a:t>
-            </a:r>
+                  <a:srgbClr val="1A3A4A"/>
+                </a:solidFill>
+                <a:latin typeface="Microsoft YaHei"/>
+              </a:rPr>
+              <a:t>服务器/云端</a:t>
+            </a:r>
+          </a:p>
+        </p:txBody>
+      </p:sp>
+      <p:sp>
+        <p:nvSpPr>
+          <p:cNvPr id="9" name="Rounded Rectangle 8"/>
+          <p:cNvSpPr/>
+          <p:nvPr/>
+        </p:nvSpPr>
+        <p:spPr>
+          <a:xfrm>
+            <a:off x="8412480" y="2103120"/>
+            <a:ext cx="2926080" cy="1828800"/>
+          </a:xfrm>
+          <a:prstGeom prst="roundRect">
+            <a:avLst/>
+          </a:prstGeom>
+          <a:solidFill>
+            <a:srgbClr val="E6F3F1"/>
+          </a:solidFill>
+          <a:ln w="12700">
+            <a:solidFill>
+              <a:srgbClr val="D0DAE0"/>
+            </a:solidFill>
+          </a:ln>
+        </p:spPr>
+        <p:style>
+          <a:lnRef idx="1">
+            <a:schemeClr val="accent1"/>
+          </a:lnRef>
+          <a:fillRef idx="3">
+            <a:schemeClr val="accent1"/>
+          </a:fillRef>
+          <a:effectRef idx="2">
+            <a:schemeClr val="accent1"/>
+          </a:effectRef>
+          <a:fontRef idx="minor">
+            <a:schemeClr val="lt1"/>
+          </a:fontRef>
+        </p:style>
+        <p:txBody>
+          <a:bodyPr rtlCol="0" anchor="ctr"/>
+          <a:lstStyle/>
+          <a:p>
+            <a:pPr algn="ctr"/>
           </a:p>
         </p:txBody>
       </p:sp>
@@ -5714,8 +6220,8 @@
         </p:nvSpPr>
         <p:spPr>
           <a:xfrm>
-            <a:off x="6583680" y="2194560"/>
-            <a:ext cx="4754880" cy="2560320"/>
+            <a:off x="8549640" y="2651760"/>
+            <a:ext cx="2651760" cy="731520"/>
           </a:xfrm>
           <a:prstGeom prst="rect">
             <a:avLst/>
@@ -5728,51 +6234,15 @@
           </a:bodyPr>
           <a:lstStyle/>
           <a:p>
-            <a:pPr algn="l"/>
-            <a:r>
-              <a:rPr sz="2200" b="0">
+            <a:pPr algn="ctr"/>
+            <a:r>
+              <a:rPr sz="2400" b="1">
                 <a:solidFill>
                   <a:srgbClr val="1A3A4A"/>
                 </a:solidFill>
                 <a:latin typeface="Microsoft YaHei"/>
               </a:rPr>
-              <a:t>如果每辆车都像手机一样</a:t>
-            </a:r>
-          </a:p>
-          <a:p>
-            <a:pPr algn="l"/>
-            <a:r>
-              <a:rPr sz="2200" b="0">
-                <a:solidFill>
-                  <a:srgbClr val="1A3A4A"/>
-                </a:solidFill>
-                <a:latin typeface="Microsoft YaHei"/>
-              </a:rPr>
-              <a:t>又快又费电——现实吗？</a:t>
-            </a:r>
-          </a:p>
-          <a:p>
-            <a:pPr algn="l"/>
-            <a:r>
-              <a:rPr sz="2200" b="0">
-                <a:solidFill>
-                  <a:srgbClr val="1A3A4A"/>
-                </a:solidFill>
-                <a:latin typeface="Microsoft YaHei"/>
-              </a:rPr>
-              <a:t/>
-            </a:r>
-          </a:p>
-          <a:p>
-            <a:pPr algn="l"/>
-            <a:r>
-              <a:rPr sz="2200" b="0">
-                <a:solidFill>
-                  <a:srgbClr val="1A3A4A"/>
-                </a:solidFill>
-                <a:latin typeface="Microsoft YaHei"/>
-              </a:rPr>
-              <a:t>？</a:t>
+              <a:t>共享单车</a:t>
             </a:r>
           </a:p>
         </p:txBody>
@@ -5785,8 +6255,8 @@
         </p:nvSpPr>
         <p:spPr>
           <a:xfrm>
-            <a:off x="457200" y="6446520"/>
-            <a:ext cx="10972800" cy="320040"/>
+            <a:off x="548640" y="4572000"/>
+            <a:ext cx="10972800" cy="1188720"/>
           </a:xfrm>
           <a:prstGeom prst="rect">
             <a:avLst/>
@@ -5801,13 +6271,72 @@
           <a:p>
             <a:pPr algn="l"/>
             <a:r>
-              <a:rPr sz="1400" b="0">
+              <a:rPr sz="2200" b="0">
+                <a:solidFill>
+                  <a:srgbClr val="1A3A4A"/>
+                </a:solidFill>
+                <a:latin typeface="Microsoft YaHei"/>
+              </a:rPr>
+              <a:t>手指比划15秒：手机 ↔ 服务器 ↔ 单车</a:t>
+            </a:r>
+          </a:p>
+          <a:p>
+            <a:pPr algn="l"/>
+            <a:r>
+              <a:rPr sz="2200" b="0">
+                <a:solidFill>
+                  <a:srgbClr val="1A3A4A"/>
+                </a:solidFill>
+                <a:latin typeface="Microsoft YaHei"/>
+              </a:rPr>
+              <a:t>（有时还有 手机 ↔ 单车）</a:t>
+            </a:r>
+          </a:p>
+          <a:p>
+            <a:pPr algn="l"/>
+            <a:r>
+              <a:rPr sz="2200" b="0">
+                <a:solidFill>
+                  <a:srgbClr val="1A3A4A"/>
+                </a:solidFill>
+                <a:latin typeface="Microsoft YaHei"/>
+              </a:rPr>
+              <a:t>→ 任务2：给每条线找通道</a:t>
+            </a:r>
+          </a:p>
+        </p:txBody>
+      </p:sp>
+      <p:sp>
+        <p:nvSpPr>
+          <p:cNvPr id="12" name="TextBox 11"/>
+          <p:cNvSpPr txBox="1"/>
+          <p:nvPr/>
+        </p:nvSpPr>
+        <p:spPr>
+          <a:xfrm>
+            <a:off x="457200" y="6446520"/>
+            <a:ext cx="11247120" cy="320040"/>
+          </a:xfrm>
+          <a:prstGeom prst="rect">
+            <a:avLst/>
+          </a:prstGeom>
+          <a:noFill/>
+        </p:spPr>
+        <p:txBody>
+          <a:bodyPr wrap="square">
+            <a:spAutoFit/>
+          </a:bodyPr>
+          <a:lstStyle/>
+          <a:p>
+            <a:pPr algn="l"/>
+            <a:r>
+              <a:rPr sz="1300" b="0">
                 <a:solidFill>
                   <a:srgbClr val="5A6A72"/>
                 </a:solidFill>
                 <a:latin typeface="Microsoft YaHei"/>
               </a:rPr>
-              <a:t>先投票再揭晓｜约2分钟</a:t>
+              <a:t>任务1完成标志：学生能指出三条关系</a:t>
             </a:r>
           </a:p>
         </p:txBody>
@@ -5845,7 +6374,7 @@
             <a:avLst/>
           </a:prstGeom>
           <a:solidFill>
-            <a:srgbClr val="F7F9FB"/>
+            <a:srgbClr val="F4F7F8"/>
           </a:solidFill>
           <a:ln>
             <a:noFill/>
@@ -5925,7 +6454,7 @@
         <p:spPr>
           <a:xfrm>
             <a:off x="548640" y="320040"/>
-            <a:ext cx="10972800" cy="548640"/>
+            <a:ext cx="10972800" cy="502920"/>
           </a:xfrm>
           <a:prstGeom prst="rect">
             <a:avLst/>
@@ -5946,7 +6475,7 @@
                 </a:solidFill>
                 <a:latin typeface="Microsoft YaHei"/>
               </a:rPr>
-              <a:t>揭晓：找车时的两种通道</a:t>
+              <a:t>任务2·找车：手机用什么通道？</a:t>
             </a:r>
           </a:p>
         </p:txBody>
@@ -5960,13 +6489,13 @@
         <p:spPr>
           <a:xfrm>
             <a:off x="548640" y="1188720"/>
-            <a:ext cx="5303520" cy="4114800"/>
+            <a:ext cx="10972800" cy="4114800"/>
           </a:xfrm>
           <a:prstGeom prst="roundRect">
             <a:avLst/>
           </a:prstGeom>
           <a:solidFill>
-            <a:srgbClr val="E6F3F1"/>
+            <a:srgbClr val="FFFFFF"/>
           </a:solidFill>
           <a:ln w="12700">
             <a:solidFill>
@@ -6004,8 +6533,8 @@
         </p:nvSpPr>
         <p:spPr>
           <a:xfrm>
-            <a:off x="822960" y="1463040"/>
-            <a:ext cx="4754880" cy="457200"/>
+            <a:off x="914400" y="1645920"/>
+            <a:ext cx="10058400" cy="3200400"/>
           </a:xfrm>
           <a:prstGeom prst="rect">
             <a:avLst/>
@@ -6020,13 +6549,85 @@
           <a:p>
             <a:pPr algn="l"/>
             <a:r>
-              <a:rPr sz="2600" b="1">
-                <a:solidFill>
-                  <a:srgbClr val="0D7A6F"/>
-                </a:solidFill>
-                <a:latin typeface="Microsoft YaHei"/>
-              </a:rPr>
-              <a:t>手机 · 4G/5G</a:t>
+              <a:rPr sz="2600" b="0">
+                <a:solidFill>
+                  <a:srgbClr val="1A3A4A"/>
+                </a:solidFill>
+                <a:latin typeface="Microsoft YaHei"/>
+              </a:rPr>
+              <a:t>小程序怎么知道附近有车？手机这边投票：</a:t>
+            </a:r>
+          </a:p>
+          <a:p>
+            <a:pPr algn="l"/>
+            <a:r>
+              <a:rPr sz="2600" b="0">
+                <a:solidFill>
+                  <a:srgbClr val="1A3A4A"/>
+                </a:solidFill>
+                <a:latin typeface="Microsoft YaHei"/>
+              </a:rPr>
+              <a:t/>
+            </a:r>
+          </a:p>
+          <a:p>
+            <a:pPr algn="l"/>
+            <a:r>
+              <a:rPr sz="2600" b="0">
+                <a:solidFill>
+                  <a:srgbClr val="1A3A4A"/>
+                </a:solidFill>
+                <a:latin typeface="Microsoft YaHei"/>
+              </a:rPr>
+              <a:t>A. 只用 Wi-Fi 就够了</a:t>
+            </a:r>
+          </a:p>
+          <a:p>
+            <a:pPr algn="l"/>
+            <a:r>
+              <a:rPr sz="2600" b="0">
+                <a:solidFill>
+                  <a:srgbClr val="1A3A4A"/>
+                </a:solidFill>
+                <a:latin typeface="Microsoft YaHei"/>
+              </a:rPr>
+              <a:t>B. 出门常用 4G/5G</a:t>
+            </a:r>
+          </a:p>
+          <a:p>
+            <a:pPr algn="l"/>
+            <a:r>
+              <a:rPr sz="2600" b="0">
+                <a:solidFill>
+                  <a:srgbClr val="1A3A4A"/>
+                </a:solidFill>
+                <a:latin typeface="Microsoft YaHei"/>
+              </a:rPr>
+              <a:t>C. 必须插网线</a:t>
+            </a:r>
+          </a:p>
+          <a:p>
+            <a:pPr algn="l"/>
+            <a:r>
+              <a:rPr sz="2600" b="0">
+                <a:solidFill>
+                  <a:srgbClr val="1A3A4A"/>
+                </a:solidFill>
+                <a:latin typeface="Microsoft YaHei"/>
+              </a:rPr>
+              <a:t/>
+            </a:r>
+          </a:p>
+          <a:p>
+            <a:pPr algn="l"/>
+            <a:r>
+              <a:rPr sz="2600" b="0">
+                <a:solidFill>
+                  <a:srgbClr val="1A3A4A"/>
+                </a:solidFill>
+                <a:latin typeface="Microsoft YaHei"/>
+              </a:rPr>
+              <a:t>请举手选 B 的……</a:t>
             </a:r>
           </a:p>
         </p:txBody>
@@ -6039,8 +6640,8 @@
         </p:nvSpPr>
         <p:spPr>
           <a:xfrm>
-            <a:off x="822960" y="2194560"/>
-            <a:ext cx="4754880" cy="2560320"/>
+            <a:off x="457200" y="6446520"/>
+            <a:ext cx="11247120" cy="320040"/>
           </a:xfrm>
           <a:prstGeom prst="rect">
             <a:avLst/>
@@ -6055,283 +6656,13 @@
           <a:p>
             <a:pPr algn="l"/>
             <a:r>
-              <a:rPr sz="2200" b="0">
-                <a:solidFill>
-                  <a:srgbClr val="1A3A4A"/>
-                </a:solidFill>
-                <a:latin typeface="Microsoft YaHei"/>
-              </a:rPr>
-              <a:t>人话标签：高速通道</a:t>
-            </a:r>
-          </a:p>
-          <a:p>
-            <a:pPr algn="l"/>
-            <a:r>
-              <a:rPr sz="2200" b="0">
-                <a:solidFill>
-                  <a:srgbClr val="1A3A4A"/>
-                </a:solidFill>
-                <a:latin typeface="Microsoft YaHei"/>
-              </a:rPr>
-              <a:t/>
-            </a:r>
-          </a:p>
-          <a:p>
-            <a:pPr algn="l"/>
-            <a:r>
-              <a:rPr sz="2200" b="0">
-                <a:solidFill>
-                  <a:srgbClr val="1A3A4A"/>
-                </a:solidFill>
-                <a:latin typeface="Microsoft YaHei"/>
-              </a:rPr>
-              <a:t>上传位置/请求</a:t>
-            </a:r>
-          </a:p>
-          <a:p>
-            <a:pPr algn="l"/>
-            <a:r>
-              <a:rPr sz="2200" b="0">
-                <a:solidFill>
-                  <a:srgbClr val="1A3A4A"/>
-                </a:solidFill>
-                <a:latin typeface="Microsoft YaHei"/>
-              </a:rPr>
-              <a:t>拉取附近车辆列表</a:t>
-            </a:r>
-          </a:p>
-          <a:p>
-            <a:pPr algn="l"/>
-            <a:r>
-              <a:rPr sz="2200" b="0">
-                <a:solidFill>
-                  <a:srgbClr val="1A3A4A"/>
-                </a:solidFill>
-                <a:latin typeface="Microsoft YaHei"/>
-              </a:rPr>
-              <a:t/>
-            </a:r>
-          </a:p>
-          <a:p>
-            <a:pPr algn="l"/>
-            <a:r>
-              <a:rPr sz="2200" b="0">
-                <a:solidFill>
-                  <a:srgbClr val="1A3A4A"/>
-                </a:solidFill>
-                <a:latin typeface="Microsoft YaHei"/>
-              </a:rPr>
-              <a:t>特点：快，但相对费电</a:t>
-            </a:r>
-          </a:p>
-        </p:txBody>
-      </p:sp>
-      <p:sp>
-        <p:nvSpPr>
-          <p:cNvPr id="8" name="Rounded Rectangle 7"/>
-          <p:cNvSpPr/>
-          <p:nvPr/>
-        </p:nvSpPr>
-        <p:spPr>
-          <a:xfrm>
-            <a:off x="6309360" y="1188720"/>
-            <a:ext cx="5303520" cy="4114800"/>
-          </a:xfrm>
-          <a:prstGeom prst="roundRect">
-            <a:avLst/>
-          </a:prstGeom>
-          <a:solidFill>
-            <a:srgbClr val="E6F3F1"/>
-          </a:solidFill>
-          <a:ln w="12700">
-            <a:solidFill>
-              <a:srgbClr val="D0DAE0"/>
-            </a:solidFill>
-          </a:ln>
-        </p:spPr>
-        <p:style>
-          <a:lnRef idx="1">
-            <a:schemeClr val="accent1"/>
-          </a:lnRef>
-          <a:fillRef idx="3">
-            <a:schemeClr val="accent1"/>
-          </a:fillRef>
-          <a:effectRef idx="2">
-            <a:schemeClr val="accent1"/>
-          </a:effectRef>
-          <a:fontRef idx="minor">
-            <a:schemeClr val="lt1"/>
-          </a:fontRef>
-        </p:style>
-        <p:txBody>
-          <a:bodyPr rtlCol="0" anchor="ctr"/>
-          <a:lstStyle/>
-          <a:p>
-            <a:pPr algn="ctr"/>
-          </a:p>
-        </p:txBody>
-      </p:sp>
-      <p:sp>
-        <p:nvSpPr>
-          <p:cNvPr id="9" name="TextBox 8"/>
-          <p:cNvSpPr txBox="1"/>
-          <p:nvPr/>
-        </p:nvSpPr>
-        <p:spPr>
-          <a:xfrm>
-            <a:off x="6583680" y="1463040"/>
-            <a:ext cx="4754880" cy="548640"/>
-          </a:xfrm>
-          <a:prstGeom prst="rect">
-            <a:avLst/>
-          </a:prstGeom>
-          <a:noFill/>
-        </p:spPr>
-        <p:txBody>
-          <a:bodyPr wrap="square">
-            <a:spAutoFit/>
-          </a:bodyPr>
-          <a:lstStyle/>
-          <a:p>
-            <a:pPr algn="l"/>
-            <a:r>
-              <a:rPr sz="2600" b="1">
-                <a:solidFill>
-                  <a:srgbClr val="C45C26"/>
-                </a:solidFill>
-                <a:latin typeface="Microsoft YaHei"/>
-              </a:rPr>
-              <a:t>单车 · NB-IoT</a:t>
-            </a:r>
-          </a:p>
-        </p:txBody>
-      </p:sp>
-      <p:sp>
-        <p:nvSpPr>
-          <p:cNvPr id="10" name="TextBox 9"/>
-          <p:cNvSpPr txBox="1"/>
-          <p:nvPr/>
-        </p:nvSpPr>
-        <p:spPr>
-          <a:xfrm>
-            <a:off x="6583680" y="2194560"/>
-            <a:ext cx="4754880" cy="2560320"/>
-          </a:xfrm>
-          <a:prstGeom prst="rect">
-            <a:avLst/>
-          </a:prstGeom>
-          <a:noFill/>
-        </p:spPr>
-        <p:txBody>
-          <a:bodyPr wrap="square">
-            <a:spAutoFit/>
-          </a:bodyPr>
-          <a:lstStyle/>
-          <a:p>
-            <a:pPr algn="l"/>
-            <a:r>
-              <a:rPr sz="2200" b="0">
-                <a:solidFill>
-                  <a:srgbClr val="1A3A4A"/>
-                </a:solidFill>
-                <a:latin typeface="Microsoft YaHei"/>
-              </a:rPr>
-              <a:t>人话标签：省电长跑通道</a:t>
-            </a:r>
-          </a:p>
-          <a:p>
-            <a:pPr algn="l"/>
-            <a:r>
-              <a:rPr sz="2200" b="0">
-                <a:solidFill>
-                  <a:srgbClr val="1A3A4A"/>
-                </a:solidFill>
-                <a:latin typeface="Microsoft YaHei"/>
-              </a:rPr>
-              <a:t>（窄带物联网）</a:t>
-            </a:r>
-          </a:p>
-          <a:p>
-            <a:pPr algn="l"/>
-            <a:r>
-              <a:rPr sz="2200" b="0">
-                <a:solidFill>
-                  <a:srgbClr val="1A3A4A"/>
-                </a:solidFill>
-                <a:latin typeface="Microsoft YaHei"/>
-              </a:rPr>
-              <a:t/>
-            </a:r>
-          </a:p>
-          <a:p>
-            <a:pPr algn="l"/>
-            <a:r>
-              <a:rPr sz="2200" b="0">
-                <a:solidFill>
-                  <a:srgbClr val="1A3A4A"/>
-                </a:solidFill>
-                <a:latin typeface="Microsoft YaHei"/>
-              </a:rPr>
-              <a:t>上报位置等小数据</a:t>
-            </a:r>
-          </a:p>
-          <a:p>
-            <a:pPr algn="l"/>
-            <a:r>
-              <a:rPr sz="2200" b="0">
-                <a:solidFill>
-                  <a:srgbClr val="1A3A4A"/>
-                </a:solidFill>
-                <a:latin typeface="Microsoft YaHei"/>
-              </a:rPr>
-              <a:t/>
-            </a:r>
-          </a:p>
-          <a:p>
-            <a:pPr algn="l"/>
-            <a:r>
-              <a:rPr sz="2200" b="0">
-                <a:solidFill>
-                  <a:srgbClr val="1A3A4A"/>
-                </a:solidFill>
-                <a:latin typeface="Microsoft YaHei"/>
-              </a:rPr>
-              <a:t>超低功耗 · 信号稳 · 传得远</a:t>
-            </a:r>
-          </a:p>
-        </p:txBody>
-      </p:sp>
-      <p:sp>
-        <p:nvSpPr>
-          <p:cNvPr id="11" name="TextBox 10"/>
-          <p:cNvSpPr txBox="1"/>
-          <p:nvPr/>
-        </p:nvSpPr>
-        <p:spPr>
-          <a:xfrm>
-            <a:off x="457200" y="6446520"/>
-            <a:ext cx="10972800" cy="320040"/>
-          </a:xfrm>
-          <a:prstGeom prst="rect">
-            <a:avLst/>
-          </a:prstGeom>
-          <a:noFill/>
-        </p:spPr>
-        <p:txBody>
-          <a:bodyPr wrap="square">
-            <a:spAutoFit/>
-          </a:bodyPr>
-          <a:lstStyle/>
-          <a:p>
-            <a:pPr algn="l"/>
-            <a:r>
-              <a:rPr sz="1400" b="0">
+              <a:rPr sz="1300" b="0">
                 <a:solidFill>
                   <a:srgbClr val="5A6A72"/>
                 </a:solidFill>
                 <a:latin typeface="Microsoft YaHei"/>
               </a:rPr>
-              <a:t>齐答填空：找车时，手机走____，单车走____</a:t>
+              <a:t>全班投票20秒｜再问单车能不能一直跑很费电的高速通道</a:t>
             </a:r>
           </a:p>
         </p:txBody>
@@ -6369,7 +6700,7 @@
             <a:avLst/>
           </a:prstGeom>
           <a:solidFill>
-            <a:srgbClr val="F7F9FB"/>
+            <a:srgbClr val="F4F7F8"/>
           </a:solidFill>
           <a:ln>
             <a:noFill/>
@@ -6449,7 +6780,7 @@
         <p:spPr>
           <a:xfrm>
             <a:off x="548640" y="320040"/>
-            <a:ext cx="10972800" cy="548640"/>
+            <a:ext cx="10972800" cy="502920"/>
           </a:xfrm>
           <a:prstGeom prst="rect">
             <a:avLst/>
@@ -6464,13 +6795,13 @@
           <a:p>
             <a:pPr algn="l"/>
             <a:r>
-              <a:rPr sz="2800" b="1">
+              <a:rPr sz="3000" b="1">
                 <a:solidFill>
                   <a:srgbClr val="1A3A4A"/>
                 </a:solidFill>
                 <a:latin typeface="Microsoft YaHei"/>
               </a:rPr>
-              <a:t>任务2·情境B：扫码后，如何打开“这一辆”？</a:t>
+              <a:t>找车揭晓：两种通道分工</a:t>
             </a:r>
           </a:p>
         </p:txBody>
@@ -6483,14 +6814,14 @@
         </p:nvSpPr>
         <p:spPr>
           <a:xfrm>
-            <a:off x="548640" y="1188720"/>
-            <a:ext cx="10972800" cy="1828800"/>
+            <a:off x="548640" y="1143000"/>
+            <a:ext cx="5303520" cy="4114800"/>
           </a:xfrm>
           <a:prstGeom prst="roundRect">
             <a:avLst/>
           </a:prstGeom>
           <a:solidFill>
-            <a:srgbClr val="FFFFFF"/>
+            <a:srgbClr val="E6F3F1"/>
           </a:solidFill>
           <a:ln w="12700">
             <a:solidFill>
@@ -6528,8 +6859,8 @@
         </p:nvSpPr>
         <p:spPr>
           <a:xfrm>
-            <a:off x="822960" y="1463040"/>
-            <a:ext cx="10424160" cy="1280160"/>
+            <a:off x="822960" y="1417320"/>
+            <a:ext cx="4754880" cy="457200"/>
           </a:xfrm>
           <a:prstGeom prst="rect">
             <a:avLst/>
@@ -6544,25 +6875,13 @@
           <a:p>
             <a:pPr algn="l"/>
             <a:r>
-              <a:rPr sz="2400" b="1">
-                <a:solidFill>
-                  <a:srgbClr val="1A3A4A"/>
-                </a:solidFill>
-                <a:latin typeface="Microsoft YaHei"/>
-              </a:rPr>
-              <a:t>① 手机扫码得到车辆身份 → 经 4G/5G 向服务器发送【开锁请求】</a:t>
-            </a:r>
-          </a:p>
-          <a:p>
-            <a:pPr algn="l"/>
-            <a:r>
-              <a:rPr sz="2400" b="1">
-                <a:solidFill>
-                  <a:srgbClr val="1A3A4A"/>
-                </a:solidFill>
-                <a:latin typeface="Microsoft YaHei"/>
-              </a:rPr>
-              <a:t>② 服务器 → 经 NB-IoT 向该车发送【开锁指令】</a:t>
+              <a:rPr sz="2600" b="1">
+                <a:solidFill>
+                  <a:srgbClr val="0D7A6F"/>
+                </a:solidFill>
+                <a:latin typeface="Microsoft YaHei"/>
+              </a:rPr>
+              <a:t>手机 · 4G/5G</a:t>
             </a:r>
           </a:p>
         </p:txBody>
@@ -6575,8 +6894,8 @@
         </p:nvSpPr>
         <p:spPr>
           <a:xfrm>
-            <a:off x="548640" y="3383280"/>
-            <a:ext cx="10972800" cy="1828800"/>
+            <a:off x="822960" y="2103120"/>
+            <a:ext cx="4754880" cy="2743200"/>
           </a:xfrm>
           <a:prstGeom prst="rect">
             <a:avLst/>
@@ -6591,39 +6910,108 @@
           <a:p>
             <a:pPr algn="l"/>
             <a:r>
-              <a:rPr sz="2400" b="0">
-                <a:solidFill>
-                  <a:srgbClr val="0D7A6F"/>
-                </a:solidFill>
-                <a:latin typeface="Microsoft YaHei"/>
-              </a:rPr>
-              <a:t>同桌互说一遍，必须用上两个词：</a:t>
-            </a:r>
-          </a:p>
-          <a:p>
-            <a:pPr algn="l"/>
-            <a:r>
-              <a:rPr sz="2400" b="0">
-                <a:solidFill>
-                  <a:srgbClr val="0D7A6F"/>
-                </a:solidFill>
-                <a:latin typeface="Microsoft YaHei"/>
-              </a:rPr>
-              <a:t>“开锁请求” 和 “开锁指令”</a:t>
-            </a:r>
-          </a:p>
-        </p:txBody>
-      </p:sp>
-      <p:sp>
-        <p:nvSpPr>
-          <p:cNvPr id="8" name="TextBox 7"/>
+              <a:rPr sz="2200" b="0">
+                <a:solidFill>
+                  <a:srgbClr val="1A3A4A"/>
+                </a:solidFill>
+                <a:latin typeface="Microsoft YaHei"/>
+              </a:rPr>
+              <a:t>人话：高速通道</a:t>
+            </a:r>
+          </a:p>
+          <a:p>
+            <a:pPr algn="l"/>
+            <a:r>
+              <a:rPr sz="2200" b="0">
+                <a:solidFill>
+                  <a:srgbClr val="1A3A4A"/>
+                </a:solidFill>
+                <a:latin typeface="Microsoft YaHei"/>
+              </a:rPr>
+              <a:t/>
+            </a:r>
+          </a:p>
+          <a:p>
+            <a:pPr algn="l"/>
+            <a:r>
+              <a:rPr sz="2200" b="0">
+                <a:solidFill>
+                  <a:srgbClr val="1A3A4A"/>
+                </a:solidFill>
+                <a:latin typeface="Microsoft YaHei"/>
+              </a:rPr>
+              <a:t>发请求 / 拉车辆列表</a:t>
+            </a:r>
+          </a:p>
+          <a:p>
+            <a:pPr algn="l"/>
+            <a:r>
+              <a:rPr sz="2200" b="0">
+                <a:solidFill>
+                  <a:srgbClr val="1A3A4A"/>
+                </a:solidFill>
+                <a:latin typeface="Microsoft YaHei"/>
+              </a:rPr>
+              <a:t>快，但相对费电</a:t>
+            </a:r>
+          </a:p>
+        </p:txBody>
+      </p:sp>
+      <p:sp>
+        <p:nvSpPr>
+          <p:cNvPr id="8" name="Rounded Rectangle 7"/>
+          <p:cNvSpPr/>
+          <p:nvPr/>
+        </p:nvSpPr>
+        <p:spPr>
+          <a:xfrm>
+            <a:off x="6309360" y="1143000"/>
+            <a:ext cx="5303520" cy="4114800"/>
+          </a:xfrm>
+          <a:prstGeom prst="roundRect">
+            <a:avLst/>
+          </a:prstGeom>
+          <a:solidFill>
+            <a:srgbClr val="E6F3F1"/>
+          </a:solidFill>
+          <a:ln w="12700">
+            <a:solidFill>
+              <a:srgbClr val="D0DAE0"/>
+            </a:solidFill>
+          </a:ln>
+        </p:spPr>
+        <p:style>
+          <a:lnRef idx="1">
+            <a:schemeClr val="accent1"/>
+          </a:lnRef>
+          <a:fillRef idx="3">
+            <a:schemeClr val="accent1"/>
+          </a:fillRef>
+          <a:effectRef idx="2">
+            <a:schemeClr val="accent1"/>
+          </a:effectRef>
+          <a:fontRef idx="minor">
+            <a:schemeClr val="lt1"/>
+          </a:fontRef>
+        </p:style>
+        <p:txBody>
+          <a:bodyPr rtlCol="0" anchor="ctr"/>
+          <a:lstStyle/>
+          <a:p>
+            <a:pPr algn="ctr"/>
+          </a:p>
+        </p:txBody>
+      </p:sp>
+      <p:sp>
+        <p:nvSpPr>
+          <p:cNvPr id="9" name="TextBox 8"/>
           <p:cNvSpPr txBox="1"/>
           <p:nvPr/>
         </p:nvSpPr>
         <p:spPr>
           <a:xfrm>
-            <a:off x="457200" y="6446520"/>
-            <a:ext cx="10972800" cy="320040"/>
+            <a:off x="6583680" y="1417320"/>
+            <a:ext cx="4754880" cy="457200"/>
           </a:xfrm>
           <a:prstGeom prst="rect">
             <a:avLst/>
@@ -6638,13 +7026,119 @@
           <a:p>
             <a:pPr algn="l"/>
             <a:r>
-              <a:rPr sz="1400" b="0">
+              <a:rPr sz="2600" b="1">
+                <a:solidFill>
+                  <a:srgbClr val="C45C26"/>
+                </a:solidFill>
+                <a:latin typeface="Microsoft YaHei"/>
+              </a:rPr>
+              <a:t>单车 · NB-IoT</a:t>
+            </a:r>
+          </a:p>
+        </p:txBody>
+      </p:sp>
+      <p:sp>
+        <p:nvSpPr>
+          <p:cNvPr id="10" name="TextBox 9"/>
+          <p:cNvSpPr txBox="1"/>
+          <p:nvPr/>
+        </p:nvSpPr>
+        <p:spPr>
+          <a:xfrm>
+            <a:off x="6583680" y="2103120"/>
+            <a:ext cx="4754880" cy="2743200"/>
+          </a:xfrm>
+          <a:prstGeom prst="rect">
+            <a:avLst/>
+          </a:prstGeom>
+          <a:noFill/>
+        </p:spPr>
+        <p:txBody>
+          <a:bodyPr wrap="square">
+            <a:spAutoFit/>
+          </a:bodyPr>
+          <a:lstStyle/>
+          <a:p>
+            <a:pPr algn="l"/>
+            <a:r>
+              <a:rPr sz="2200" b="0">
+                <a:solidFill>
+                  <a:srgbClr val="1A3A4A"/>
+                </a:solidFill>
+                <a:latin typeface="Microsoft YaHei"/>
+              </a:rPr>
+              <a:t>人话：省电长跑通道</a:t>
+            </a:r>
+          </a:p>
+          <a:p>
+            <a:pPr algn="l"/>
+            <a:r>
+              <a:rPr sz="2200" b="0">
+                <a:solidFill>
+                  <a:srgbClr val="1A3A4A"/>
+                </a:solidFill>
+                <a:latin typeface="Microsoft YaHei"/>
+              </a:rPr>
+              <a:t/>
+            </a:r>
+          </a:p>
+          <a:p>
+            <a:pPr algn="l"/>
+            <a:r>
+              <a:rPr sz="2200" b="0">
+                <a:solidFill>
+                  <a:srgbClr val="1A3A4A"/>
+                </a:solidFill>
+                <a:latin typeface="Microsoft YaHei"/>
+              </a:rPr>
+              <a:t>上报位置等小数据</a:t>
+            </a:r>
+          </a:p>
+          <a:p>
+            <a:pPr algn="l"/>
+            <a:r>
+              <a:rPr sz="2200" b="0">
+                <a:solidFill>
+                  <a:srgbClr val="1A3A4A"/>
+                </a:solidFill>
+                <a:latin typeface="Microsoft YaHei"/>
+              </a:rPr>
+              <a:t>省电 · 稳 · 远</a:t>
+            </a:r>
+          </a:p>
+        </p:txBody>
+      </p:sp>
+      <p:sp>
+        <p:nvSpPr>
+          <p:cNvPr id="11" name="TextBox 10"/>
+          <p:cNvSpPr txBox="1"/>
+          <p:nvPr/>
+        </p:nvSpPr>
+        <p:spPr>
+          <a:xfrm>
+            <a:off x="457200" y="6446520"/>
+            <a:ext cx="11247120" cy="320040"/>
+          </a:xfrm>
+          <a:prstGeom prst="rect">
+            <a:avLst/>
+          </a:prstGeom>
+          <a:noFill/>
+        </p:spPr>
+        <p:txBody>
+          <a:bodyPr wrap="square">
+            <a:spAutoFit/>
+          </a:bodyPr>
+          <a:lstStyle/>
+          <a:p>
+            <a:pPr algn="l"/>
+            <a:r>
+              <a:rPr sz="1300" b="0">
                 <a:solidFill>
                   <a:srgbClr val="5A6A72"/>
                 </a:solidFill>
                 <a:latin typeface="Microsoft YaHei"/>
               </a:rPr>
-              <a:t>允许合理的其他流程，给予肯定（教材提示）</a:t>
+              <a:t>齐答：找车时手机走____，单车走____</a:t>
             </a:r>
           </a:p>
         </p:txBody>
@@ -6682,7 +7176,7 @@
             <a:avLst/>
           </a:prstGeom>
           <a:solidFill>
-            <a:srgbClr val="F7F9FB"/>
+            <a:srgbClr val="F4F7F8"/>
           </a:solidFill>
           <a:ln>
             <a:noFill/>
@@ -6761,8 +7255,8 @@
         </p:nvSpPr>
         <p:spPr>
           <a:xfrm>
-            <a:off x="548640" y="320040"/>
-            <a:ext cx="10972800" cy="548640"/>
+            <a:off x="548640" y="274320"/>
+            <a:ext cx="10972800" cy="457200"/>
           </a:xfrm>
           <a:prstGeom prst="rect">
             <a:avLst/>
@@ -6777,13 +7271,13 @@
           <a:p>
             <a:pPr algn="l"/>
             <a:r>
-              <a:rPr sz="3200" b="1">
+              <a:rPr sz="3000" b="1">
                 <a:solidFill>
                   <a:srgbClr val="1A3A4A"/>
                 </a:solidFill>
                 <a:latin typeface="Microsoft YaHei"/>
               </a:rPr>
-              <a:t>如果信号不好，还能开锁吗？</a:t>
+              <a:t>任务2·开锁：请求 / 指令</a:t>
             </a:r>
           </a:p>
         </p:txBody>
@@ -6796,8 +7290,124 @@
         </p:nvSpPr>
         <p:spPr>
           <a:xfrm>
-            <a:off x="2286000" y="1645920"/>
-            <a:ext cx="7589520" cy="3200400"/>
+            <a:off x="548640" y="914400"/>
+            <a:ext cx="10972800" cy="2286000"/>
+          </a:xfrm>
+          <a:prstGeom prst="roundRect">
+            <a:avLst/>
+          </a:prstGeom>
+          <a:solidFill>
+            <a:srgbClr val="FFFFFF"/>
+          </a:solidFill>
+          <a:ln w="12700">
+            <a:solidFill>
+              <a:srgbClr val="D0DAE0"/>
+            </a:solidFill>
+          </a:ln>
+        </p:spPr>
+        <p:style>
+          <a:lnRef idx="1">
+            <a:schemeClr val="accent1"/>
+          </a:lnRef>
+          <a:fillRef idx="3">
+            <a:schemeClr val="accent1"/>
+          </a:fillRef>
+          <a:effectRef idx="2">
+            <a:schemeClr val="accent1"/>
+          </a:effectRef>
+          <a:fontRef idx="minor">
+            <a:schemeClr val="lt1"/>
+          </a:fontRef>
+        </p:style>
+        <p:txBody>
+          <a:bodyPr rtlCol="0" anchor="ctr"/>
+          <a:lstStyle/>
+          <a:p>
+            <a:pPr algn="ctr"/>
+          </a:p>
+        </p:txBody>
+      </p:sp>
+      <p:sp>
+        <p:nvSpPr>
+          <p:cNvPr id="6" name="TextBox 5"/>
+          <p:cNvSpPr txBox="1"/>
+          <p:nvPr/>
+        </p:nvSpPr>
+        <p:spPr>
+          <a:xfrm>
+            <a:off x="822960" y="1143000"/>
+            <a:ext cx="10424160" cy="1828800"/>
+          </a:xfrm>
+          <a:prstGeom prst="rect">
+            <a:avLst/>
+          </a:prstGeom>
+          <a:noFill/>
+        </p:spPr>
+        <p:txBody>
+          <a:bodyPr wrap="square">
+            <a:spAutoFit/>
+          </a:bodyPr>
+          <a:lstStyle/>
+          <a:p>
+            <a:pPr algn="l"/>
+            <a:r>
+              <a:rPr sz="2400" b="1">
+                <a:solidFill>
+                  <a:srgbClr val="1A3A4A"/>
+                </a:solidFill>
+                <a:latin typeface="Microsoft YaHei"/>
+              </a:rPr>
+              <a:t>① 手机 → 服务器：4G/5G 发送【开锁请求】</a:t>
+            </a:r>
+          </a:p>
+          <a:p>
+            <a:pPr algn="l"/>
+            <a:r>
+              <a:rPr sz="2400" b="1">
+                <a:solidFill>
+                  <a:srgbClr val="1A3A4A"/>
+                </a:solidFill>
+                <a:latin typeface="Microsoft YaHei"/>
+              </a:rPr>
+              <a:t>② 服务器 → 单车：NB-IoT 发送【开锁指令】</a:t>
+            </a:r>
+          </a:p>
+          <a:p>
+            <a:pPr algn="l"/>
+            <a:r>
+              <a:rPr sz="2400" b="1">
+                <a:solidFill>
+                  <a:srgbClr val="1A3A4A"/>
+                </a:solidFill>
+                <a:latin typeface="Microsoft YaHei"/>
+              </a:rPr>
+              <a:t/>
+            </a:r>
+          </a:p>
+          <a:p>
+            <a:pPr algn="l"/>
+            <a:r>
+              <a:rPr sz="2400" b="1">
+                <a:solidFill>
+                  <a:srgbClr val="1A3A4A"/>
+                </a:solidFill>
+                <a:latin typeface="Microsoft YaHei"/>
+              </a:rPr>
+              <a:t>同桌12秒互说，必须用上这两个词</a:t>
+            </a:r>
+          </a:p>
+        </p:txBody>
+      </p:sp>
+      <p:sp>
+        <p:nvSpPr>
+          <p:cNvPr id="7" name="Rounded Rectangle 6"/>
+          <p:cNvSpPr/>
+          <p:nvPr/>
+        </p:nvSpPr>
+        <p:spPr>
+          <a:xfrm>
+            <a:off x="548640" y="3474720"/>
+            <a:ext cx="10972800" cy="2194560"/>
           </a:xfrm>
           <a:prstGeom prst="roundRect">
             <a:avLst/>
@@ -6835,14 +7445,14 @@
       </p:sp>
       <p:sp>
         <p:nvSpPr>
-          <p:cNvPr id="6" name="TextBox 5"/>
+          <p:cNvPr id="8" name="TextBox 7"/>
           <p:cNvSpPr txBox="1"/>
           <p:nvPr/>
         </p:nvSpPr>
         <p:spPr>
           <a:xfrm>
-            <a:off x="2743200" y="2011680"/>
-            <a:ext cx="6675120" cy="548640"/>
+            <a:off x="822960" y="3749039"/>
+            <a:ext cx="10424160" cy="1645920"/>
           </a:xfrm>
           <a:prstGeom prst="rect">
             <a:avLst/>
@@ -6855,29 +7465,53 @@
           </a:bodyPr>
           <a:lstStyle/>
           <a:p>
-            <a:pPr algn="ctr"/>
-            <a:r>
-              <a:rPr sz="2800" b="1">
-                <a:solidFill>
-                  <a:srgbClr val="0D7A6F"/>
-                </a:solidFill>
-                <a:latin typeface="Microsoft YaHei"/>
-              </a:rPr>
-              <a:t>蓝牙 · 贴身短距通道</a:t>
-            </a:r>
-          </a:p>
-        </p:txBody>
-      </p:sp>
-      <p:sp>
-        <p:nvSpPr>
-          <p:cNvPr id="7" name="TextBox 6"/>
+            <a:pPr algn="l"/>
+            <a:r>
+              <a:rPr sz="2200" b="0">
+                <a:solidFill>
+                  <a:srgbClr val="1A3A4A"/>
+                </a:solidFill>
+                <a:latin typeface="Microsoft YaHei"/>
+              </a:rPr>
+              <a:t>AI-2 问小青：</a:t>
+            </a:r>
+          </a:p>
+          <a:p>
+            <a:pPr algn="l"/>
+            <a:r>
+              <a:rPr sz="2200" b="0">
+                <a:solidFill>
+                  <a:srgbClr val="1A3A4A"/>
+                </a:solidFill>
+                <a:latin typeface="Microsoft YaHei"/>
+              </a:rPr>
+              <a:t>「地下室信号差，只靠 NB-IoT 开锁够不够？还要什么？」</a:t>
+            </a:r>
+          </a:p>
+          <a:p>
+            <a:pPr algn="l"/>
+            <a:r>
+              <a:rPr sz="2200" b="0">
+                <a:solidFill>
+                  <a:srgbClr val="1A3A4A"/>
+                </a:solidFill>
+                <a:latin typeface="Microsoft YaHei"/>
+              </a:rPr>
+              <a:t>→ 引出：蓝牙（贴身短距通道）</a:t>
+            </a:r>
+          </a:p>
+        </p:txBody>
+      </p:sp>
+      <p:sp>
+        <p:nvSpPr>
+          <p:cNvPr id="9" name="TextBox 8"/>
           <p:cNvSpPr txBox="1"/>
           <p:nvPr/>
         </p:nvSpPr>
         <p:spPr>
           <a:xfrm>
-            <a:off x="2743200" y="2834640"/>
-            <a:ext cx="6675120" cy="1645920"/>
+            <a:off x="457200" y="6446520"/>
+            <a:ext cx="11247120" cy="320040"/>
           </a:xfrm>
           <a:prstGeom prst="rect">
             <a:avLst/>
@@ -6890,62 +7524,15 @@
           </a:bodyPr>
           <a:lstStyle/>
           <a:p>
-            <a:pPr algn="ctr"/>
-            <a:r>
-              <a:rPr sz="2400" b="0">
-                <a:solidFill>
-                  <a:srgbClr val="1A3A4A"/>
-                </a:solidFill>
-                <a:latin typeface="Microsoft YaHei"/>
-              </a:rPr>
-              <a:t>无网 / 弱网也能辅助连接</a:t>
-            </a:r>
-          </a:p>
-          <a:p>
-            <a:pPr algn="ctr"/>
-            <a:r>
-              <a:rPr sz="2400" b="0">
-                <a:solidFill>
-                  <a:srgbClr val="1A3A4A"/>
-                </a:solidFill>
-                <a:latin typeface="Microsoft YaHei"/>
-              </a:rPr>
-              <a:t>距离短 · 数据量小 · 适合辅助开锁</a:t>
-            </a:r>
-          </a:p>
-        </p:txBody>
-      </p:sp>
-      <p:sp>
-        <p:nvSpPr>
-          <p:cNvPr id="8" name="TextBox 7"/>
-          <p:cNvSpPr txBox="1"/>
-          <p:nvPr/>
-        </p:nvSpPr>
-        <p:spPr>
-          <a:xfrm>
-            <a:off x="457200" y="6446520"/>
-            <a:ext cx="10972800" cy="320040"/>
-          </a:xfrm>
-          <a:prstGeom prst="rect">
-            <a:avLst/>
-          </a:prstGeom>
-          <a:noFill/>
-        </p:spPr>
-        <p:txBody>
-          <a:bodyPr wrap="square">
-            <a:spAutoFit/>
-          </a:bodyPr>
-          <a:lstStyle/>
-          <a:p>
-            <a:pPr algn="l"/>
-            <a:r>
-              <a:rPr sz="1400" b="0">
+            <a:pPr algn="l"/>
+            <a:r>
+              <a:rPr sz="1300" b="0">
                 <a:solidFill>
                   <a:srgbClr val="5A6A72"/>
                 </a:solidFill>
                 <a:latin typeface="Microsoft YaHei"/>
               </a:rPr>
-              <a:t>问题引出，不要先放答案｜约1.5分钟</a:t>
+              <a:t>学生先猜，再看AI｜然后全班判断小青对不对</a:t>
             </a:r>
           </a:p>
         </p:txBody>
@@ -6983,7 +7570,7 @@
             <a:avLst/>
           </a:prstGeom>
           <a:solidFill>
-            <a:srgbClr val="F7F9FB"/>
+            <a:srgbClr val="F4F7F8"/>
           </a:solidFill>
           <a:ln>
             <a:noFill/>
@@ -7062,8 +7649,8 @@
         </p:nvSpPr>
         <p:spPr>
           <a:xfrm>
-            <a:off x="548640" y="320040"/>
-            <a:ext cx="10972800" cy="548640"/>
+            <a:off x="548640" y="274320"/>
+            <a:ext cx="10972800" cy="457200"/>
           </a:xfrm>
           <a:prstGeom prst="rect">
             <a:avLst/>
@@ -7084,7 +7671,7 @@
                 </a:solidFill>
                 <a:latin typeface="Microsoft YaHei"/>
               </a:rPr>
-              <a:t>核心部件——智能车锁（一眼看懂）</a:t>
+              <a:t>弱网补位 + 智能车锁</a:t>
             </a:r>
           </a:p>
         </p:txBody>
@@ -7097,8 +7684,171 @@
         </p:nvSpPr>
         <p:spPr>
           <a:xfrm>
-            <a:off x="548640" y="1097280"/>
-            <a:ext cx="10972800" cy="914400"/>
+            <a:off x="548640" y="914400"/>
+            <a:ext cx="5303520" cy="4754880"/>
+          </a:xfrm>
+          <a:prstGeom prst="roundRect">
+            <a:avLst/>
+          </a:prstGeom>
+          <a:solidFill>
+            <a:srgbClr val="E6F3F1"/>
+          </a:solidFill>
+          <a:ln w="12700">
+            <a:solidFill>
+              <a:srgbClr val="D0DAE0"/>
+            </a:solidFill>
+          </a:ln>
+        </p:spPr>
+        <p:style>
+          <a:lnRef idx="1">
+            <a:schemeClr val="accent1"/>
+          </a:lnRef>
+          <a:fillRef idx="3">
+            <a:schemeClr val="accent1"/>
+          </a:fillRef>
+          <a:effectRef idx="2">
+            <a:schemeClr val="accent1"/>
+          </a:effectRef>
+          <a:fontRef idx="minor">
+            <a:schemeClr val="lt1"/>
+          </a:fontRef>
+        </p:style>
+        <p:txBody>
+          <a:bodyPr rtlCol="0" anchor="ctr"/>
+          <a:lstStyle/>
+          <a:p>
+            <a:pPr algn="ctr"/>
+          </a:p>
+        </p:txBody>
+      </p:sp>
+      <p:sp>
+        <p:nvSpPr>
+          <p:cNvPr id="6" name="TextBox 5"/>
+          <p:cNvSpPr txBox="1"/>
+          <p:nvPr/>
+        </p:nvSpPr>
+        <p:spPr>
+          <a:xfrm>
+            <a:off x="822960" y="1188720"/>
+            <a:ext cx="4754880" cy="457200"/>
+          </a:xfrm>
+          <a:prstGeom prst="rect">
+            <a:avLst/>
+          </a:prstGeom>
+          <a:noFill/>
+        </p:spPr>
+        <p:txBody>
+          <a:bodyPr wrap="square">
+            <a:spAutoFit/>
+          </a:bodyPr>
+          <a:lstStyle/>
+          <a:p>
+            <a:pPr algn="l"/>
+            <a:r>
+              <a:rPr sz="2600" b="1">
+                <a:solidFill>
+                  <a:srgbClr val="0D7A6F"/>
+                </a:solidFill>
+                <a:latin typeface="Microsoft YaHei"/>
+              </a:rPr>
+              <a:t>蓝牙</a:t>
+            </a:r>
+          </a:p>
+        </p:txBody>
+      </p:sp>
+      <p:sp>
+        <p:nvSpPr>
+          <p:cNvPr id="7" name="TextBox 6"/>
+          <p:cNvSpPr txBox="1"/>
+          <p:nvPr/>
+        </p:nvSpPr>
+        <p:spPr>
+          <a:xfrm>
+            <a:off x="822960" y="1920240"/>
+            <a:ext cx="4754880" cy="3200400"/>
+          </a:xfrm>
+          <a:prstGeom prst="rect">
+            <a:avLst/>
+          </a:prstGeom>
+          <a:noFill/>
+        </p:spPr>
+        <p:txBody>
+          <a:bodyPr wrap="square">
+            <a:spAutoFit/>
+          </a:bodyPr>
+          <a:lstStyle/>
+          <a:p>
+            <a:pPr algn="l"/>
+            <a:r>
+              <a:rPr sz="2200" b="0">
+                <a:solidFill>
+                  <a:srgbClr val="1A3A4A"/>
+                </a:solidFill>
+                <a:latin typeface="Microsoft YaHei"/>
+              </a:rPr>
+              <a:t>人话：贴身短距通道</a:t>
+            </a:r>
+          </a:p>
+          <a:p>
+            <a:pPr algn="l"/>
+            <a:r>
+              <a:rPr sz="2200" b="0">
+                <a:solidFill>
+                  <a:srgbClr val="1A3A4A"/>
+                </a:solidFill>
+                <a:latin typeface="Microsoft YaHei"/>
+              </a:rPr>
+              <a:t/>
+            </a:r>
+          </a:p>
+          <a:p>
+            <a:pPr algn="l"/>
+            <a:r>
+              <a:rPr sz="2200" b="0">
+                <a:solidFill>
+                  <a:srgbClr val="1A3A4A"/>
+                </a:solidFill>
+                <a:latin typeface="Microsoft YaHei"/>
+              </a:rPr>
+              <a:t>无网 / 弱网也能连</a:t>
+            </a:r>
+          </a:p>
+          <a:p>
+            <a:pPr algn="l"/>
+            <a:r>
+              <a:rPr sz="2200" b="0">
+                <a:solidFill>
+                  <a:srgbClr val="1A3A4A"/>
+                </a:solidFill>
+                <a:latin typeface="Microsoft YaHei"/>
+              </a:rPr>
+              <a:t>距离短 · 数据小</a:t>
+            </a:r>
+          </a:p>
+          <a:p>
+            <a:pPr algn="l"/>
+            <a:r>
+              <a:rPr sz="2200" b="0">
+                <a:solidFill>
+                  <a:srgbClr val="1A3A4A"/>
+                </a:solidFill>
+                <a:latin typeface="Microsoft YaHei"/>
+              </a:rPr>
+              <a:t>适合辅助开锁</a:t>
+            </a:r>
+          </a:p>
+        </p:txBody>
+      </p:sp>
+      <p:sp>
+        <p:nvSpPr>
+          <p:cNvPr id="8" name="Rounded Rectangle 7"/>
+          <p:cNvSpPr/>
+          <p:nvPr/>
+        </p:nvSpPr>
+        <p:spPr>
+          <a:xfrm>
+            <a:off x="6309360" y="914400"/>
+            <a:ext cx="5303520" cy="4754880"/>
           </a:xfrm>
           <a:prstGeom prst="roundRect">
             <a:avLst/>
@@ -7136,14 +7886,14 @@
       </p:sp>
       <p:sp>
         <p:nvSpPr>
-          <p:cNvPr id="6" name="TextBox 5"/>
+          <p:cNvPr id="9" name="TextBox 8"/>
           <p:cNvSpPr txBox="1"/>
           <p:nvPr/>
         </p:nvSpPr>
         <p:spPr>
           <a:xfrm>
-            <a:off x="822960" y="1325880"/>
-            <a:ext cx="3200400" cy="457200"/>
+            <a:off x="6583680" y="1188720"/>
+            <a:ext cx="4754880" cy="457200"/>
           </a:xfrm>
           <a:prstGeom prst="rect">
             <a:avLst/>
@@ -7164,21 +7914,21 @@
                 </a:solidFill>
                 <a:latin typeface="Microsoft YaHei"/>
               </a:rPr>
-              <a:t>微控制器</a:t>
-            </a:r>
-          </a:p>
-        </p:txBody>
-      </p:sp>
-      <p:sp>
-        <p:nvSpPr>
-          <p:cNvPr id="7" name="TextBox 6"/>
+              <a:t>智能车锁模块</a:t>
+            </a:r>
+          </a:p>
+        </p:txBody>
+      </p:sp>
+      <p:sp>
+        <p:nvSpPr>
+          <p:cNvPr id="10" name="TextBox 9"/>
           <p:cNvSpPr txBox="1"/>
           <p:nvPr/>
         </p:nvSpPr>
         <p:spPr>
           <a:xfrm>
-            <a:off x="4114800" y="1325880"/>
-            <a:ext cx="6858000" cy="457200"/>
+            <a:off x="6583680" y="1828800"/>
+            <a:ext cx="4754880" cy="3474720"/>
           </a:xfrm>
           <a:prstGeom prst="rect">
             <a:avLst/>
@@ -7193,72 +7943,99 @@
           <a:p>
             <a:pPr algn="l"/>
             <a:r>
-              <a:rPr sz="2200" b="0">
+              <a:rPr sz="2000" b="0">
                 <a:solidFill>
                   <a:srgbClr val="1A3A4A"/>
                 </a:solidFill>
                 <a:latin typeface="Microsoft YaHei"/>
               </a:rPr>
-              <a:t>控制整把锁（大脑）</a:t>
-            </a:r>
-          </a:p>
-        </p:txBody>
-      </p:sp>
-      <p:sp>
-        <p:nvSpPr>
-          <p:cNvPr id="8" name="Rounded Rectangle 7"/>
-          <p:cNvSpPr/>
-          <p:nvPr/>
-        </p:nvSpPr>
-        <p:spPr>
-          <a:xfrm>
-            <a:off x="548640" y="2148839"/>
-            <a:ext cx="10972800" cy="914400"/>
-          </a:xfrm>
-          <a:prstGeom prst="roundRect">
-            <a:avLst/>
-          </a:prstGeom>
-          <a:solidFill>
-            <a:srgbClr val="FFFFFF"/>
-          </a:solidFill>
-          <a:ln w="12700">
-            <a:solidFill>
-              <a:srgbClr val="D0DAE0"/>
-            </a:solidFill>
-          </a:ln>
-        </p:spPr>
-        <p:style>
-          <a:lnRef idx="1">
-            <a:schemeClr val="accent1"/>
-          </a:lnRef>
-          <a:fillRef idx="3">
-            <a:schemeClr val="accent1"/>
-          </a:fillRef>
-          <a:effectRef idx="2">
-            <a:schemeClr val="accent1"/>
-          </a:effectRef>
-          <a:fontRef idx="minor">
-            <a:schemeClr val="lt1"/>
-          </a:fontRef>
-        </p:style>
-        <p:txBody>
-          <a:bodyPr rtlCol="0" anchor="ctr"/>
-          <a:lstStyle/>
-          <a:p>
-            <a:pPr algn="ctr"/>
-          </a:p>
-        </p:txBody>
-      </p:sp>
-      <p:sp>
-        <p:nvSpPr>
-          <p:cNvPr id="9" name="TextBox 8"/>
+              <a:t>微控制器（大脑）</a:t>
+            </a:r>
+          </a:p>
+          <a:p>
+            <a:pPr algn="l"/>
+            <a:r>
+              <a:rPr sz="2000" b="0">
+                <a:solidFill>
+                  <a:srgbClr val="1A3A4A"/>
+                </a:solidFill>
+                <a:latin typeface="Microsoft YaHei"/>
+              </a:rPr>
+              <a:t>电池</a:t>
+            </a:r>
+          </a:p>
+          <a:p>
+            <a:pPr algn="l"/>
+            <a:r>
+              <a:rPr sz="2000" b="0">
+                <a:solidFill>
+                  <a:srgbClr val="1A3A4A"/>
+                </a:solidFill>
+                <a:latin typeface="Microsoft YaHei"/>
+              </a:rPr>
+              <a:t>GPS 定位</a:t>
+            </a:r>
+          </a:p>
+          <a:p>
+            <a:pPr algn="l"/>
+            <a:r>
+              <a:rPr sz="2000" b="0">
+                <a:solidFill>
+                  <a:srgbClr val="1A3A4A"/>
+                </a:solidFill>
+                <a:latin typeface="Microsoft YaHei"/>
+              </a:rPr>
+              <a:t>数据传输模块 ←</a:t>
+            </a:r>
+          </a:p>
+          <a:p>
+            <a:pPr algn="l"/>
+            <a:r>
+              <a:rPr sz="2000" b="0">
+                <a:solidFill>
+                  <a:srgbClr val="1A3A4A"/>
+                </a:solidFill>
+                <a:latin typeface="Microsoft YaHei"/>
+              </a:rPr>
+              <a:t>NB-IoT / 蓝牙 / 4G Cat.1</a:t>
+            </a:r>
+          </a:p>
+          <a:p>
+            <a:pPr algn="l"/>
+            <a:r>
+              <a:rPr sz="2000" b="0">
+                <a:solidFill>
+                  <a:srgbClr val="1A3A4A"/>
+                </a:solidFill>
+                <a:latin typeface="Microsoft YaHei"/>
+              </a:rPr>
+              <a:t/>
+            </a:r>
+          </a:p>
+          <a:p>
+            <a:pPr algn="l"/>
+            <a:r>
+              <a:rPr sz="2000" b="0">
+                <a:solidFill>
+                  <a:srgbClr val="1A3A4A"/>
+                </a:solidFill>
+                <a:latin typeface="Microsoft YaHei"/>
+              </a:rPr>
+              <a:t>齐答：一种不够，多种配合</a:t>
+            </a:r>
+          </a:p>
+        </p:txBody>
+      </p:sp>
+      <p:sp>
+        <p:nvSpPr>
+          <p:cNvPr id="11" name="TextBox 10"/>
           <p:cNvSpPr txBox="1"/>
           <p:nvPr/>
         </p:nvSpPr>
         <p:spPr>
           <a:xfrm>
-            <a:off x="822960" y="2377439"/>
-            <a:ext cx="3200400" cy="457200"/>
+            <a:off x="457200" y="6446520"/>
+            <a:ext cx="11247120" cy="320040"/>
           </a:xfrm>
           <a:prstGeom prst="rect">
             <a:avLst/>
@@ -7273,313 +8050,13 @@
           <a:p>
             <a:pPr algn="l"/>
             <a:r>
-              <a:rPr sz="2200" b="1">
-                <a:solidFill>
-                  <a:srgbClr val="1A3A4A"/>
-                </a:solidFill>
-                <a:latin typeface="Microsoft YaHei"/>
-              </a:rPr>
-              <a:t>电池</a:t>
-            </a:r>
-          </a:p>
-        </p:txBody>
-      </p:sp>
-      <p:sp>
-        <p:nvSpPr>
-          <p:cNvPr id="10" name="TextBox 9"/>
-          <p:cNvSpPr txBox="1"/>
-          <p:nvPr/>
-        </p:nvSpPr>
-        <p:spPr>
-          <a:xfrm>
-            <a:off x="4114800" y="2377439"/>
-            <a:ext cx="6858000" cy="457200"/>
-          </a:xfrm>
-          <a:prstGeom prst="rect">
-            <a:avLst/>
-          </a:prstGeom>
-          <a:noFill/>
-        </p:spPr>
-        <p:txBody>
-          <a:bodyPr wrap="square">
-            <a:spAutoFit/>
-          </a:bodyPr>
-          <a:lstStyle/>
-          <a:p>
-            <a:pPr algn="l"/>
-            <a:r>
-              <a:rPr sz="2200" b="0">
-                <a:solidFill>
-                  <a:srgbClr val="1A3A4A"/>
-                </a:solidFill>
-                <a:latin typeface="Microsoft YaHei"/>
-              </a:rPr>
-              <a:t>为智能锁供电</a:t>
-            </a:r>
-          </a:p>
-        </p:txBody>
-      </p:sp>
-      <p:sp>
-        <p:nvSpPr>
-          <p:cNvPr id="11" name="Rounded Rectangle 10"/>
-          <p:cNvSpPr/>
-          <p:nvPr/>
-        </p:nvSpPr>
-        <p:spPr>
-          <a:xfrm>
-            <a:off x="548640" y="3200400"/>
-            <a:ext cx="10972800" cy="914400"/>
-          </a:xfrm>
-          <a:prstGeom prst="roundRect">
-            <a:avLst/>
-          </a:prstGeom>
-          <a:solidFill>
-            <a:srgbClr val="FFFFFF"/>
-          </a:solidFill>
-          <a:ln w="12700">
-            <a:solidFill>
-              <a:srgbClr val="D0DAE0"/>
-            </a:solidFill>
-          </a:ln>
-        </p:spPr>
-        <p:style>
-          <a:lnRef idx="1">
-            <a:schemeClr val="accent1"/>
-          </a:lnRef>
-          <a:fillRef idx="3">
-            <a:schemeClr val="accent1"/>
-          </a:fillRef>
-          <a:effectRef idx="2">
-            <a:schemeClr val="accent1"/>
-          </a:effectRef>
-          <a:fontRef idx="minor">
-            <a:schemeClr val="lt1"/>
-          </a:fontRef>
-        </p:style>
-        <p:txBody>
-          <a:bodyPr rtlCol="0" anchor="ctr"/>
-          <a:lstStyle/>
-          <a:p>
-            <a:pPr algn="ctr"/>
-          </a:p>
-        </p:txBody>
-      </p:sp>
-      <p:sp>
-        <p:nvSpPr>
-          <p:cNvPr id="12" name="TextBox 11"/>
-          <p:cNvSpPr txBox="1"/>
-          <p:nvPr/>
-        </p:nvSpPr>
-        <p:spPr>
-          <a:xfrm>
-            <a:off x="822960" y="3429000"/>
-            <a:ext cx="3200400" cy="457200"/>
-          </a:xfrm>
-          <a:prstGeom prst="rect">
-            <a:avLst/>
-          </a:prstGeom>
-          <a:noFill/>
-        </p:spPr>
-        <p:txBody>
-          <a:bodyPr wrap="square">
-            <a:spAutoFit/>
-          </a:bodyPr>
-          <a:lstStyle/>
-          <a:p>
-            <a:pPr algn="l"/>
-            <a:r>
-              <a:rPr sz="2200" b="1">
-                <a:solidFill>
-                  <a:srgbClr val="1A3A4A"/>
-                </a:solidFill>
-                <a:latin typeface="Microsoft YaHei"/>
-              </a:rPr>
-              <a:t>GPS模块</a:t>
-            </a:r>
-          </a:p>
-        </p:txBody>
-      </p:sp>
-      <p:sp>
-        <p:nvSpPr>
-          <p:cNvPr id="13" name="TextBox 12"/>
-          <p:cNvSpPr txBox="1"/>
-          <p:nvPr/>
-        </p:nvSpPr>
-        <p:spPr>
-          <a:xfrm>
-            <a:off x="4114800" y="3429000"/>
-            <a:ext cx="6858000" cy="457200"/>
-          </a:xfrm>
-          <a:prstGeom prst="rect">
-            <a:avLst/>
-          </a:prstGeom>
-          <a:noFill/>
-        </p:spPr>
-        <p:txBody>
-          <a:bodyPr wrap="square">
-            <a:spAutoFit/>
-          </a:bodyPr>
-          <a:lstStyle/>
-          <a:p>
-            <a:pPr algn="l"/>
-            <a:r>
-              <a:rPr sz="2200" b="0">
-                <a:solidFill>
-                  <a:srgbClr val="1A3A4A"/>
-                </a:solidFill>
-                <a:latin typeface="Microsoft YaHei"/>
-              </a:rPr>
-              <a:t>定位</a:t>
-            </a:r>
-          </a:p>
-        </p:txBody>
-      </p:sp>
-      <p:sp>
-        <p:nvSpPr>
-          <p:cNvPr id="14" name="Rounded Rectangle 13"/>
-          <p:cNvSpPr/>
-          <p:nvPr/>
-        </p:nvSpPr>
-        <p:spPr>
-          <a:xfrm>
-            <a:off x="548640" y="4251959"/>
-            <a:ext cx="10972800" cy="914400"/>
-          </a:xfrm>
-          <a:prstGeom prst="roundRect">
-            <a:avLst/>
-          </a:prstGeom>
-          <a:solidFill>
-            <a:srgbClr val="E6F3F1"/>
-          </a:solidFill>
-          <a:ln w="12700">
-            <a:solidFill>
-              <a:srgbClr val="D0DAE0"/>
-            </a:solidFill>
-          </a:ln>
-        </p:spPr>
-        <p:style>
-          <a:lnRef idx="1">
-            <a:schemeClr val="accent1"/>
-          </a:lnRef>
-          <a:fillRef idx="3">
-            <a:schemeClr val="accent1"/>
-          </a:fillRef>
-          <a:effectRef idx="2">
-            <a:schemeClr val="accent1"/>
-          </a:effectRef>
-          <a:fontRef idx="minor">
-            <a:schemeClr val="lt1"/>
-          </a:fontRef>
-        </p:style>
-        <p:txBody>
-          <a:bodyPr rtlCol="0" anchor="ctr"/>
-          <a:lstStyle/>
-          <a:p>
-            <a:pPr algn="ctr"/>
-          </a:p>
-        </p:txBody>
-      </p:sp>
-      <p:sp>
-        <p:nvSpPr>
-          <p:cNvPr id="15" name="TextBox 14"/>
-          <p:cNvSpPr txBox="1"/>
-          <p:nvPr/>
-        </p:nvSpPr>
-        <p:spPr>
-          <a:xfrm>
-            <a:off x="822960" y="4480559"/>
-            <a:ext cx="3200400" cy="457200"/>
-          </a:xfrm>
-          <a:prstGeom prst="rect">
-            <a:avLst/>
-          </a:prstGeom>
-          <a:noFill/>
-        </p:spPr>
-        <p:txBody>
-          <a:bodyPr wrap="square">
-            <a:spAutoFit/>
-          </a:bodyPr>
-          <a:lstStyle/>
-          <a:p>
-            <a:pPr algn="l"/>
-            <a:r>
-              <a:rPr sz="2200" b="1">
-                <a:solidFill>
-                  <a:srgbClr val="0D7A6F"/>
-                </a:solidFill>
-                <a:latin typeface="Microsoft YaHei"/>
-              </a:rPr>
-              <a:t>数据传输模块</a:t>
-            </a:r>
-          </a:p>
-        </p:txBody>
-      </p:sp>
-      <p:sp>
-        <p:nvSpPr>
-          <p:cNvPr id="16" name="TextBox 15"/>
-          <p:cNvSpPr txBox="1"/>
-          <p:nvPr/>
-        </p:nvSpPr>
-        <p:spPr>
-          <a:xfrm>
-            <a:off x="4114800" y="4480559"/>
-            <a:ext cx="6858000" cy="457200"/>
-          </a:xfrm>
-          <a:prstGeom prst="rect">
-            <a:avLst/>
-          </a:prstGeom>
-          <a:noFill/>
-        </p:spPr>
-        <p:txBody>
-          <a:bodyPr wrap="square">
-            <a:spAutoFit/>
-          </a:bodyPr>
-          <a:lstStyle/>
-          <a:p>
-            <a:pPr algn="l"/>
-            <a:r>
-              <a:rPr sz="2200" b="1">
-                <a:solidFill>
-                  <a:srgbClr val="1A3A4A"/>
-                </a:solidFill>
-                <a:latin typeface="Microsoft YaHei"/>
-              </a:rPr>
-              <a:t>常为 NB-IoT、蓝牙、4G Cat.1</a:t>
-            </a:r>
-          </a:p>
-        </p:txBody>
-      </p:sp>
-      <p:sp>
-        <p:nvSpPr>
-          <p:cNvPr id="17" name="TextBox 16"/>
-          <p:cNvSpPr txBox="1"/>
-          <p:nvPr/>
-        </p:nvSpPr>
-        <p:spPr>
-          <a:xfrm>
-            <a:off x="457200" y="6446520"/>
-            <a:ext cx="10972800" cy="320040"/>
-          </a:xfrm>
-          <a:prstGeom prst="rect">
-            <a:avLst/>
-          </a:prstGeom>
-          <a:noFill/>
-        </p:spPr>
-        <p:txBody>
-          <a:bodyPr wrap="square">
-            <a:spAutoFit/>
-          </a:bodyPr>
-          <a:lstStyle/>
-          <a:p>
-            <a:pPr algn="l"/>
-            <a:r>
-              <a:rPr sz="1400" b="0">
+              <a:rPr sz="1300" b="0">
                 <a:solidFill>
                   <a:srgbClr val="5A6A72"/>
                 </a:solidFill>
                 <a:latin typeface="Microsoft YaHei"/>
               </a:rPr>
-              <a:t>齐答：一种方式不够，多种方式配合</a:t>
+              <a:t>任务2完成标志：三通道都能对上场景</a:t>
             </a:r>
           </a:p>
         </p:txBody>

</xml_diff>